<commit_message>
Update ToyTrade presentation slides with technical security architecture parameters
</commit_message>
<xml_diff>
--- a/toytrade_pitch.pptx
+++ b/toytrade_pitch.pptx
@@ -5,14 +5,15 @@
     <p:sldMasterId xmlns:r="http://schemas.openxmlformats.org/officeDocument/2006/relationships" id="2147483648" r:id="rId1"/>
   </p:sldMasterIdLst>
   <p:notesMasterIdLst>
-    <p:notesMasterId r:id="Ref43082bca29405f"/>
+    <p:notesMasterId r:id="R40169b48c31b4aea"/>
   </p:notesMasterIdLst>
   <p:sldIdLst>
-    <p:sldId id="256" r:id="R2c468f8cb41b4ede"/>
-    <p:sldId id="257" r:id="R73c543caf0b54299"/>
-    <p:sldId id="258" r:id="Rd0dded0d04114e6d"/>
-    <p:sldId id="259" r:id="R12df726148b147f2"/>
-    <p:sldId id="260" r:id="R586ac000c47b4c8e"/>
+    <p:sldId id="256" r:id="R47aee234effe4ad5"/>
+    <p:sldId id="257" r:id="Rb29dad6a3fab4d3c"/>
+    <p:sldId id="258" r:id="R2c9503aac3f74295"/>
+    <p:sldId id="259" r:id="R678311e0561b41b2"/>
+    <p:sldId id="260" r:id="R11697261741144e9"/>
+    <p:sldId id="261" r:id="Rc0713e1c64644aa8"/>
   </p:sldIdLst>
   <p:sldSz cx="12192000" cy="6858000"/>
   <p:notesSz cx="6858000" cy="9144000"/>
@@ -695,6 +696,61 @@
           <a:p xmlns:a="http://schemas.openxmlformats.org/drawingml/2006/main">
             <a:r>
               <a:rPr lang="en-US"/>
+              <a:t>Explain the MVP's technical limitations and security parameters that are documented in the README. Highlight transaction hijacking, unauthenticated confirmations, and off-chain price oracle fixes.</a:t>
+            </a:r>
+          </a:p>
+        </p:txBody>
+      </p:sp>
+    </p:spTree>
+  </p:cSld>
+  <p:clrMapOvr>
+    <a:masterClrMapping xmlns:a="http://schemas.openxmlformats.org/drawingml/2006/main"/>
+  </p:clrMapOvr>
+</p:notes>
+</file>
+
+<file path=ppt/notesSlides/notesSlide6.xml><?xml version="1.0" encoding="utf-8"?>
+<p:notes xmlns:p="http://schemas.openxmlformats.org/presentationml/2006/main">
+  <p:cSld>
+    <p:spTree>
+      <p:nvGrpSpPr>
+        <p:cNvPr id="1" name=""/>
+        <p:cNvGrpSpPr/>
+        <p:nvPr/>
+      </p:nvGrpSpPr>
+      <p:grpSpPr>
+        <a:xfrm xmlns:a="http://schemas.openxmlformats.org/drawingml/2006/main"/>
+      </p:grpSpPr>
+      <p:sp>
+        <p:nvSpPr>
+          <p:cNvPr id="2" name="Slide Image Placeholder 1"/>
+          <p:cNvSpPr/>
+          <p:nvPr>
+            <p:ph type="sldImg" idx="0"/>
+          </p:nvPr>
+        </p:nvSpPr>
+        <p:spPr/>
+        <p:txBody>
+          <a:bodyPr xmlns:a="http://schemas.openxmlformats.org/drawingml/2006/main"/>
+          <a:lstStyle xmlns:a="http://schemas.openxmlformats.org/drawingml/2006/main"/>
+          <a:p xmlns:a="http://schemas.openxmlformats.org/drawingml/2006/main"/>
+        </p:txBody>
+      </p:sp>
+      <p:sp>
+        <p:nvSpPr>
+          <p:cNvPr id="3" name="Notes Placeholder 2"/>
+          <p:cNvSpPr/>
+          <p:nvPr>
+            <p:ph type="body" idx="1"/>
+          </p:nvPr>
+        </p:nvSpPr>
+        <p:spPr/>
+        <p:txBody>
+          <a:bodyPr xmlns:a="http://schemas.openxmlformats.org/drawingml/2006/main"/>
+          <a:lstStyle xmlns:a="http://schemas.openxmlformats.org/drawingml/2006/main"/>
+          <a:p xmlns:a="http://schemas.openxmlformats.org/drawingml/2006/main">
+            <a:r>
+              <a:rPr lang="en-US"/>
               <a:t>Outline our evolutionary roadmap from core v1 CKB escrow to instant Fiber payments and cross-chain Bitcoin support.</a:t>
             </a:r>
           </a:p>
@@ -2213,6 +2269,488 @@
     <p:bg>
       <p:bgPr>
         <a:solidFill xmlns:a="http://schemas.openxmlformats.org/drawingml/2006/main">
+          <a:srgbClr val="F9F6F0"/>
+        </a:solidFill>
+      </p:bgPr>
+    </p:bg>
+    <p:spTree>
+      <p:nvGrpSpPr>
+        <p:cNvPr id="1" name=""/>
+        <p:cNvGrpSpPr/>
+        <p:nvPr/>
+      </p:nvGrpSpPr>
+      <p:grpSpPr/>
+      <p:sp>
+        <p:nvSpPr>
+          <p:cNvPr id="100029" name="TextBox 1"/>
+          <p:cNvSpPr/>
+          <p:nvPr/>
+        </p:nvSpPr>
+        <p:spPr>
+          <a:xfrm xmlns:a="http://schemas.openxmlformats.org/drawingml/2006/main">
+            <a:off x="540000" y="457200"/>
+            <a:ext cx="11113200" cy="540000"/>
+          </a:xfrm>
+          <a:prstGeom xmlns:a="http://schemas.openxmlformats.org/drawingml/2006/main" prst="rect">
+            <a:avLst/>
+          </a:prstGeom>
+          <a:noFill xmlns:a="http://schemas.openxmlformats.org/drawingml/2006/main"/>
+        </p:spPr>
+        <p:txBody>
+          <a:bodyPr xmlns:a="http://schemas.openxmlformats.org/drawingml/2006/main"/>
+          <a:lstStyle xmlns:a="http://schemas.openxmlformats.org/drawingml/2006/main"/>
+          <a:p xmlns:a="http://schemas.openxmlformats.org/drawingml/2006/main">
+            <a:r>
+              <a:rPr lang="en-US" sz="3800" b="1">
+                <a:solidFill>
+                  <a:srgbClr val="1E2761"/>
+                </a:solidFill>
+                <a:latin typeface="Georgia"/>
+                <a:ea typeface="Georgia"/>
+              </a:rPr>
+              <a:t>MVP Technical &amp; Security Parameters</a:t>
+            </a:r>
+          </a:p>
+        </p:txBody>
+      </p:sp>
+      <p:sp>
+        <p:nvSpPr>
+          <p:cNvPr id="100030" name="TextBox 2"/>
+          <p:cNvSpPr/>
+          <p:nvPr/>
+        </p:nvSpPr>
+        <p:spPr>
+          <a:xfrm xmlns:a="http://schemas.openxmlformats.org/drawingml/2006/main">
+            <a:off x="540000" y="1260000"/>
+            <a:ext cx="3420000" cy="4680000"/>
+          </a:xfrm>
+          <a:prstGeom xmlns:a="http://schemas.openxmlformats.org/drawingml/2006/main" prst="roundRect">
+            <a:avLst/>
+          </a:prstGeom>
+          <a:solidFill xmlns:a="http://schemas.openxmlformats.org/drawingml/2006/main">
+            <a:srgbClr val="FFFFFF"/>
+          </a:solidFill>
+          <a:ln xmlns:a="http://schemas.openxmlformats.org/drawingml/2006/main">
+            <a:solidFill>
+              <a:srgbClr val="E0E0E0"/>
+            </a:solidFill>
+          </a:ln>
+        </p:spPr>
+        <p:txBody>
+          <a:bodyPr xmlns:a="http://schemas.openxmlformats.org/drawingml/2006/main"/>
+          <a:lstStyle xmlns:a="http://schemas.openxmlformats.org/drawingml/2006/main"/>
+          <a:p xmlns:a="http://schemas.openxmlformats.org/drawingml/2006/main"/>
+        </p:txBody>
+      </p:sp>
+      <p:sp>
+        <p:nvSpPr>
+          <p:cNvPr id="100031" name="TextBox 3"/>
+          <p:cNvSpPr/>
+          <p:nvPr/>
+        </p:nvSpPr>
+        <p:spPr>
+          <a:xfrm xmlns:a="http://schemas.openxmlformats.org/drawingml/2006/main">
+            <a:off x="792000" y="1512000"/>
+            <a:ext cx="2916000" cy="540000"/>
+          </a:xfrm>
+          <a:prstGeom xmlns:a="http://schemas.openxmlformats.org/drawingml/2006/main" prst="rect">
+            <a:avLst/>
+          </a:prstGeom>
+          <a:noFill xmlns:a="http://schemas.openxmlformats.org/drawingml/2006/main"/>
+        </p:spPr>
+        <p:txBody>
+          <a:bodyPr xmlns:a="http://schemas.openxmlformats.org/drawingml/2006/main"/>
+          <a:lstStyle xmlns:a="http://schemas.openxmlformats.org/drawingml/2006/main"/>
+          <a:p xmlns:a="http://schemas.openxmlformats.org/drawingml/2006/main">
+            <a:r>
+              <a:rPr lang="en-US" sz="2200" b="1">
+                <a:solidFill>
+                  <a:srgbClr val="B85042"/>
+                </a:solidFill>
+                <a:latin typeface="Georgia"/>
+                <a:ea typeface="Georgia"/>
+              </a:rPr>
+              <a:t>1. Escrow Lock</a:t>
+            </a:r>
+          </a:p>
+        </p:txBody>
+      </p:sp>
+      <p:sp>
+        <p:nvSpPr>
+          <p:cNvPr id="100032" name="TextBox 4"/>
+          <p:cNvSpPr/>
+          <p:nvPr/>
+        </p:nvSpPr>
+        <p:spPr>
+          <a:xfrm xmlns:a="http://schemas.openxmlformats.org/drawingml/2006/main">
+            <a:off x="792000" y="2160000"/>
+            <a:ext cx="2916000" cy="3600000"/>
+          </a:xfrm>
+          <a:prstGeom xmlns:a="http://schemas.openxmlformats.org/drawingml/2006/main" prst="rect">
+            <a:avLst/>
+          </a:prstGeom>
+          <a:noFill xmlns:a="http://schemas.openxmlformats.org/drawingml/2006/main"/>
+        </p:spPr>
+        <p:txBody>
+          <a:bodyPr xmlns:a="http://schemas.openxmlformats.org/drawingml/2006/main"/>
+          <a:lstStyle xmlns:a="http://schemas.openxmlformats.org/drawingml/2006/main"/>
+          <a:p xmlns:a="http://schemas.openxmlformats.org/drawingml/2006/main">
+            <a:r>
+              <a:rPr lang="en-US" sz="1600">
+                <a:solidFill>
+                  <a:srgbClr val="333333"/>
+                </a:solidFill>
+                <a:latin typeface="Calibri"/>
+                <a:ea typeface="Calibri"/>
+              </a:rPr>
+              <a:t>• Current Rule: Checks input cell lock hashes to authorize swaps.</a:t>
+            </a:r>
+          </a:p>
+          <a:p xmlns:a="http://schemas.openxmlformats.org/drawingml/2006/main">
+            <a:r>
+              <a:rPr lang="en-US" sz="1600">
+                <a:solidFill>
+                  <a:srgbClr val="333333"/>
+                </a:solidFill>
+                <a:latin typeface="Calibri"/>
+                <a:ea typeface="Calibri"/>
+              </a:rPr>
+              <a:t/>
+            </a:r>
+          </a:p>
+          <a:p xmlns:a="http://schemas.openxmlformats.org/drawingml/2006/main">
+            <a:r>
+              <a:rPr lang="en-US" sz="1600">
+                <a:solidFill>
+                  <a:srgbClr val="333333"/>
+                </a:solidFill>
+                <a:latin typeface="Calibri"/>
+                <a:ea typeface="Calibri"/>
+              </a:rPr>
+              <a:t>• MVP Risk: Lacks direct witness signature hash mapping on active cells.</a:t>
+            </a:r>
+          </a:p>
+          <a:p xmlns:a="http://schemas.openxmlformats.org/drawingml/2006/main">
+            <a:r>
+              <a:rPr lang="en-US" sz="1600">
+                <a:solidFill>
+                  <a:srgbClr val="333333"/>
+                </a:solidFill>
+                <a:latin typeface="Calibri"/>
+                <a:ea typeface="Calibri"/>
+              </a:rPr>
+              <a:t/>
+            </a:r>
+          </a:p>
+          <a:p xmlns:a="http://schemas.openxmlformats.org/drawingml/2006/main">
+            <a:r>
+              <a:rPr lang="en-US" sz="1600">
+                <a:solidFill>
+                  <a:srgbClr val="333333"/>
+                </a:solidFill>
+                <a:latin typeface="Calibri"/>
+                <a:ea typeface="Calibri"/>
+              </a:rPr>
+              <a:t>• Production Fix: Enforce cryptographic witness signatures inside the Rust smart contract execution.</a:t>
+            </a:r>
+          </a:p>
+        </p:txBody>
+      </p:sp>
+      <p:sp>
+        <p:nvSpPr>
+          <p:cNvPr id="100033" name="TextBox 5"/>
+          <p:cNvSpPr/>
+          <p:nvPr/>
+        </p:nvSpPr>
+        <p:spPr>
+          <a:xfrm xmlns:a="http://schemas.openxmlformats.org/drawingml/2006/main">
+            <a:off x="4320000" y="1260000"/>
+            <a:ext cx="3420000" cy="4680000"/>
+          </a:xfrm>
+          <a:prstGeom xmlns:a="http://schemas.openxmlformats.org/drawingml/2006/main" prst="roundRect">
+            <a:avLst/>
+          </a:prstGeom>
+          <a:solidFill xmlns:a="http://schemas.openxmlformats.org/drawingml/2006/main">
+            <a:srgbClr val="FFFFFF"/>
+          </a:solidFill>
+          <a:ln xmlns:a="http://schemas.openxmlformats.org/drawingml/2006/main">
+            <a:solidFill>
+              <a:srgbClr val="E0E0E0"/>
+            </a:solidFill>
+          </a:ln>
+        </p:spPr>
+        <p:txBody>
+          <a:bodyPr xmlns:a="http://schemas.openxmlformats.org/drawingml/2006/main"/>
+          <a:lstStyle xmlns:a="http://schemas.openxmlformats.org/drawingml/2006/main"/>
+          <a:p xmlns:a="http://schemas.openxmlformats.org/drawingml/2006/main"/>
+        </p:txBody>
+      </p:sp>
+      <p:sp>
+        <p:nvSpPr>
+          <p:cNvPr id="100034" name="TextBox 6"/>
+          <p:cNvSpPr/>
+          <p:nvPr/>
+        </p:nvSpPr>
+        <p:spPr>
+          <a:xfrm xmlns:a="http://schemas.openxmlformats.org/drawingml/2006/main">
+            <a:off x="4572000" y="1512000"/>
+            <a:ext cx="2916000" cy="540000"/>
+          </a:xfrm>
+          <a:prstGeom xmlns:a="http://schemas.openxmlformats.org/drawingml/2006/main" prst="rect">
+            <a:avLst/>
+          </a:prstGeom>
+          <a:noFill xmlns:a="http://schemas.openxmlformats.org/drawingml/2006/main"/>
+        </p:spPr>
+        <p:txBody>
+          <a:bodyPr xmlns:a="http://schemas.openxmlformats.org/drawingml/2006/main"/>
+          <a:lstStyle xmlns:a="http://schemas.openxmlformats.org/drawingml/2006/main"/>
+          <a:p xmlns:a="http://schemas.openxmlformats.org/drawingml/2006/main">
+            <a:r>
+              <a:rPr lang="en-US" sz="2200" b="1">
+                <a:solidFill>
+                  <a:srgbClr val="B85042"/>
+                </a:solidFill>
+                <a:latin typeface="Georgia"/>
+                <a:ea typeface="Georgia"/>
+              </a:rPr>
+              <a:t>2. API Security</a:t>
+            </a:r>
+          </a:p>
+        </p:txBody>
+      </p:sp>
+      <p:sp>
+        <p:nvSpPr>
+          <p:cNvPr id="100035" name="TextBox 7"/>
+          <p:cNvSpPr/>
+          <p:nvPr/>
+        </p:nvSpPr>
+        <p:spPr>
+          <a:xfrm xmlns:a="http://schemas.openxmlformats.org/drawingml/2006/main">
+            <a:off x="4572000" y="2160000"/>
+            <a:ext cx="2916000" cy="3600000"/>
+          </a:xfrm>
+          <a:prstGeom xmlns:a="http://schemas.openxmlformats.org/drawingml/2006/main" prst="rect">
+            <a:avLst/>
+          </a:prstGeom>
+          <a:noFill xmlns:a="http://schemas.openxmlformats.org/drawingml/2006/main"/>
+        </p:spPr>
+        <p:txBody>
+          <a:bodyPr xmlns:a="http://schemas.openxmlformats.org/drawingml/2006/main"/>
+          <a:lstStyle xmlns:a="http://schemas.openxmlformats.org/drawingml/2006/main"/>
+          <a:p xmlns:a="http://schemas.openxmlformats.org/drawingml/2006/main">
+            <a:r>
+              <a:rPr lang="en-US" sz="1600">
+                <a:solidFill>
+                  <a:srgbClr val="333333"/>
+                </a:solidFill>
+                <a:latin typeface="Calibri"/>
+                <a:ea typeface="Calibri"/>
+              </a:rPr>
+              <a:t>• Current Rule: Client sends role parameter on API route to trigger confirm.</a:t>
+            </a:r>
+          </a:p>
+          <a:p xmlns:a="http://schemas.openxmlformats.org/drawingml/2006/main">
+            <a:r>
+              <a:rPr lang="en-US" sz="1600">
+                <a:solidFill>
+                  <a:srgbClr val="333333"/>
+                </a:solidFill>
+                <a:latin typeface="Calibri"/>
+                <a:ea typeface="Calibri"/>
+              </a:rPr>
+              <a:t/>
+            </a:r>
+          </a:p>
+          <a:p xmlns:a="http://schemas.openxmlformats.org/drawingml/2006/main">
+            <a:r>
+              <a:rPr lang="en-US" sz="1600">
+                <a:solidFill>
+                  <a:srgbClr val="333333"/>
+                </a:solidFill>
+                <a:latin typeface="Calibri"/>
+                <a:ea typeface="Calibri"/>
+              </a:rPr>
+              <a:t>• MVP Risk: Unsigned HTTP requests can mock confirming actions.</a:t>
+            </a:r>
+          </a:p>
+          <a:p xmlns:a="http://schemas.openxmlformats.org/drawingml/2006/main">
+            <a:r>
+              <a:rPr lang="en-US" sz="1600">
+                <a:solidFill>
+                  <a:srgbClr val="333333"/>
+                </a:solidFill>
+                <a:latin typeface="Calibri"/>
+                <a:ea typeface="Calibri"/>
+              </a:rPr>
+              <a:t/>
+            </a:r>
+          </a:p>
+          <a:p xmlns:a="http://schemas.openxmlformats.org/drawingml/2006/main">
+            <a:r>
+              <a:rPr lang="en-US" sz="1600">
+                <a:solidFill>
+                  <a:srgbClr val="333333"/>
+                </a:solidFill>
+                <a:latin typeface="Calibri"/>
+                <a:ea typeface="Calibri"/>
+              </a:rPr>
+              <a:t>• Production Fix: Require JoyID message signatures to authenticate API requests on backend.</a:t>
+            </a:r>
+          </a:p>
+        </p:txBody>
+      </p:sp>
+      <p:sp>
+        <p:nvSpPr>
+          <p:cNvPr id="100036" name="TextBox 8"/>
+          <p:cNvSpPr/>
+          <p:nvPr/>
+        </p:nvSpPr>
+        <p:spPr>
+          <a:xfrm xmlns:a="http://schemas.openxmlformats.org/drawingml/2006/main">
+            <a:off x="8100000" y="1260000"/>
+            <a:ext cx="3420000" cy="4680000"/>
+          </a:xfrm>
+          <a:prstGeom xmlns:a="http://schemas.openxmlformats.org/drawingml/2006/main" prst="roundRect">
+            <a:avLst/>
+          </a:prstGeom>
+          <a:solidFill xmlns:a="http://schemas.openxmlformats.org/drawingml/2006/main">
+            <a:srgbClr val="1E2761"/>
+          </a:solidFill>
+          <a:ln xmlns:a="http://schemas.openxmlformats.org/drawingml/2006/main">
+            <a:noFill/>
+          </a:ln>
+        </p:spPr>
+        <p:txBody>
+          <a:bodyPr xmlns:a="http://schemas.openxmlformats.org/drawingml/2006/main"/>
+          <a:lstStyle xmlns:a="http://schemas.openxmlformats.org/drawingml/2006/main"/>
+          <a:p xmlns:a="http://schemas.openxmlformats.org/drawingml/2006/main"/>
+        </p:txBody>
+      </p:sp>
+      <p:sp>
+        <p:nvSpPr>
+          <p:cNvPr id="100037" name="TextBox 9"/>
+          <p:cNvSpPr/>
+          <p:nvPr/>
+        </p:nvSpPr>
+        <p:spPr>
+          <a:xfrm xmlns:a="http://schemas.openxmlformats.org/drawingml/2006/main">
+            <a:off x="8352000" y="1512000"/>
+            <a:ext cx="2916000" cy="540000"/>
+          </a:xfrm>
+          <a:prstGeom xmlns:a="http://schemas.openxmlformats.org/drawingml/2006/main" prst="rect">
+            <a:avLst/>
+          </a:prstGeom>
+          <a:noFill xmlns:a="http://schemas.openxmlformats.org/drawingml/2006/main"/>
+        </p:spPr>
+        <p:txBody>
+          <a:bodyPr xmlns:a="http://schemas.openxmlformats.org/drawingml/2006/main"/>
+          <a:lstStyle xmlns:a="http://schemas.openxmlformats.org/drawingml/2006/main"/>
+          <a:p xmlns:a="http://schemas.openxmlformats.org/drawingml/2006/main">
+            <a:r>
+              <a:rPr lang="en-US" sz="2200" b="1">
+                <a:solidFill>
+                  <a:srgbClr val="CADCFC"/>
+                </a:solidFill>
+                <a:latin typeface="Georgia"/>
+                <a:ea typeface="Georgia"/>
+              </a:rPr>
+              <a:t>3. Price Feeds</a:t>
+            </a:r>
+          </a:p>
+        </p:txBody>
+      </p:sp>
+      <p:sp>
+        <p:nvSpPr>
+          <p:cNvPr id="100038" name="TextBox 10"/>
+          <p:cNvSpPr/>
+          <p:nvPr/>
+        </p:nvSpPr>
+        <p:spPr>
+          <a:xfrm xmlns:a="http://schemas.openxmlformats.org/drawingml/2006/main">
+            <a:off x="8352000" y="2160000"/>
+            <a:ext cx="2916000" cy="3600000"/>
+          </a:xfrm>
+          <a:prstGeom xmlns:a="http://schemas.openxmlformats.org/drawingml/2006/main" prst="rect">
+            <a:avLst/>
+          </a:prstGeom>
+          <a:noFill xmlns:a="http://schemas.openxmlformats.org/drawingml/2006/main"/>
+        </p:spPr>
+        <p:txBody>
+          <a:bodyPr xmlns:a="http://schemas.openxmlformats.org/drawingml/2006/main"/>
+          <a:lstStyle xmlns:a="http://schemas.openxmlformats.org/drawingml/2006/main"/>
+          <a:p xmlns:a="http://schemas.openxmlformats.org/drawingml/2006/main">
+            <a:r>
+              <a:rPr lang="en-US" sz="1600">
+                <a:solidFill>
+                  <a:srgbClr val="FFFFFF"/>
+                </a:solidFill>
+                <a:latin typeface="Calibri"/>
+                <a:ea typeface="Calibri"/>
+              </a:rPr>
+              <a:t>• Current Rule: Uses CoinGecko and SerpApi visual search feeds at listing.</a:t>
+            </a:r>
+          </a:p>
+          <a:p xmlns:a="http://schemas.openxmlformats.org/drawingml/2006/main">
+            <a:r>
+              <a:rPr lang="en-US" sz="1600">
+                <a:solidFill>
+                  <a:srgbClr val="FFFFFF"/>
+                </a:solidFill>
+                <a:latin typeface="Calibri"/>
+                <a:ea typeface="Calibri"/>
+              </a:rPr>
+              <a:t/>
+            </a:r>
+          </a:p>
+          <a:p xmlns:a="http://schemas.openxmlformats.org/drawingml/2006/main">
+            <a:r>
+              <a:rPr lang="en-US" sz="1600">
+                <a:solidFill>
+                  <a:srgbClr val="FFFFFF"/>
+                </a:solidFill>
+                <a:latin typeface="Calibri"/>
+                <a:ea typeface="Calibri"/>
+              </a:rPr>
+              <a:t>• MVP Risk: Network downtime or pricing shifts affect escrow amount.</a:t>
+            </a:r>
+          </a:p>
+          <a:p xmlns:a="http://schemas.openxmlformats.org/drawingml/2006/main">
+            <a:r>
+              <a:rPr lang="en-US" sz="1600">
+                <a:solidFill>
+                  <a:srgbClr val="FFFFFF"/>
+                </a:solidFill>
+                <a:latin typeface="Calibri"/>
+                <a:ea typeface="Calibri"/>
+              </a:rPr>
+              <a:t/>
+            </a:r>
+          </a:p>
+          <a:p xmlns:a="http://schemas.openxmlformats.org/drawingml/2006/main">
+            <a:r>
+              <a:rPr lang="en-US" sz="1600">
+                <a:solidFill>
+                  <a:srgbClr val="FFFFFF"/>
+                </a:solidFill>
+                <a:latin typeface="Calibri"/>
+                <a:ea typeface="Calibri"/>
+              </a:rPr>
+              <a:t>• Production Fix: Implement on-chain oracles (e.g. DIA) to query and verify feed values.</a:t>
+            </a:r>
+          </a:p>
+        </p:txBody>
+      </p:sp>
+    </p:spTree>
+  </p:cSld>
+</p:sld>
+</file>
+
+<file path=ppt/slides/slide6.xml><?xml version="1.0" encoding="utf-8"?>
+<p:sld xmlns:p="http://schemas.openxmlformats.org/presentationml/2006/main">
+  <p:cSld>
+    <p:bg>
+      <p:bgPr>
+        <a:solidFill xmlns:a="http://schemas.openxmlformats.org/drawingml/2006/main">
           <a:srgbClr val="1E2761"/>
         </a:solidFill>
       </p:bgPr>
@@ -2226,7 +2764,7 @@
       <p:grpSpPr/>
       <p:sp>
         <p:nvSpPr>
-          <p:cNvPr id="100029" name="TextBox 1"/>
+          <p:cNvPr id="100039" name="TextBox 1"/>
           <p:cNvSpPr/>
           <p:nvPr/>
         </p:nvSpPr>
@@ -2259,7 +2797,7 @@
       </p:sp>
       <p:sp>
         <p:nvSpPr>
-          <p:cNvPr id="100030" name="TextBox 2"/>
+          <p:cNvPr id="100040" name="TextBox 2"/>
           <p:cNvSpPr/>
           <p:nvPr/>
         </p:nvSpPr>
@@ -2288,7 +2826,7 @@
       </p:sp>
       <p:sp>
         <p:nvSpPr>
-          <p:cNvPr id="100031" name="TextBox 3"/>
+          <p:cNvPr id="100041" name="TextBox 3"/>
           <p:cNvSpPr/>
           <p:nvPr/>
         </p:nvSpPr>
@@ -2321,7 +2859,7 @@
       </p:sp>
       <p:sp>
         <p:nvSpPr>
-          <p:cNvPr id="100032" name="TextBox 4"/>
+          <p:cNvPr id="100042" name="TextBox 4"/>
           <p:cNvSpPr/>
           <p:nvPr/>
         </p:nvSpPr>
@@ -2354,7 +2892,7 @@
       </p:sp>
       <p:sp>
         <p:nvSpPr>
-          <p:cNvPr id="100033" name="TextBox 5"/>
+          <p:cNvPr id="100043" name="TextBox 5"/>
           <p:cNvSpPr/>
           <p:nvPr/>
         </p:nvSpPr>
@@ -2383,7 +2921,7 @@
       </p:sp>
       <p:sp>
         <p:nvSpPr>
-          <p:cNvPr id="100034" name="TextBox 6"/>
+          <p:cNvPr id="100044" name="TextBox 6"/>
           <p:cNvSpPr/>
           <p:nvPr/>
         </p:nvSpPr>
@@ -2416,7 +2954,7 @@
       </p:sp>
       <p:sp>
         <p:nvSpPr>
-          <p:cNvPr id="100035" name="TextBox 7"/>
+          <p:cNvPr id="100045" name="TextBox 7"/>
           <p:cNvSpPr/>
           <p:nvPr/>
         </p:nvSpPr>
@@ -2449,7 +2987,7 @@
       </p:sp>
       <p:sp>
         <p:nvSpPr>
-          <p:cNvPr id="100036" name="TextBox 8"/>
+          <p:cNvPr id="100046" name="TextBox 8"/>
           <p:cNvSpPr/>
           <p:nvPr/>
         </p:nvSpPr>
@@ -2478,7 +3016,7 @@
       </p:sp>
       <p:sp>
         <p:nvSpPr>
-          <p:cNvPr id="100037" name="TextBox 9"/>
+          <p:cNvPr id="100047" name="TextBox 9"/>
           <p:cNvSpPr/>
           <p:nvPr/>
         </p:nvSpPr>
@@ -2511,7 +3049,7 @@
       </p:sp>
       <p:sp>
         <p:nvSpPr>
-          <p:cNvPr id="100038" name="TextBox 10"/>
+          <p:cNvPr id="100048" name="TextBox 10"/>
           <p:cNvSpPr/>
           <p:nvPr/>
         </p:nvSpPr>

</xml_diff>

<commit_message>
Finalize presentation deck with unified dark slate theme and icon-free layout
</commit_message>
<xml_diff>
--- a/toytrade_pitch.pptx
+++ b/toytrade_pitch.pptx
@@ -3108,7 +3108,7 @@
             <a:avLst/>
           </a:prstGeom>
           <a:solidFill>
-            <a:srgbClr val="0A1128"/>
+            <a:srgbClr val="0F172A"/>
           </a:solidFill>
           <a:ln>
             <a:noFill/>
@@ -3161,7 +3161,7 @@
             <a:pPr>
               <a:defRPr sz="5600" b="1">
                 <a:solidFill>
-                  <a:srgbClr val="00FF87"/>
+                  <a:srgbClr val="22C55E"/>
                 </a:solidFill>
               </a:defRPr>
             </a:pPr>
@@ -3181,7 +3181,7 @@
               </a:defRPr>
             </a:pPr>
             <a:r>
-              <a:t>The Trustless, Provenance-Tracked Used Toy Exchange on Nervos CKB</a:t>
+              <a:t>Trustless, Provenance-Tracked Used Toy Exchange on Nervos CKB</a:t>
             </a:r>
           </a:p>
           <a:p>
@@ -3191,12 +3191,12 @@
               </a:spcBef>
               <a:defRPr sz="1600">
                 <a:solidFill>
-                  <a:srgbClr val="60EFFF"/>
-                </a:solidFill>
-              </a:defRPr>
-            </a:pPr>
-            <a:r>
-              <a:t>A zero-friction, blockchain-powered alternative to buying new for modern parents</a:t>
+                  <a:srgbClr val="0EA5E9"/>
+                </a:solidFill>
+              </a:defRPr>
+            </a:pPr>
+            <a:r>
+              <a:t>A zero-friction, blockchain-powered alternative to buying new</a:t>
             </a:r>
           </a:p>
         </p:txBody>
@@ -3210,17 +3210,17 @@
         <p:spPr>
           <a:xfrm>
             <a:off x="914400" y="4389120"/>
-            <a:ext cx="2377440" cy="822960"/>
+            <a:ext cx="2377440" cy="731520"/>
           </a:xfrm>
           <a:prstGeom prst="roundRect">
             <a:avLst/>
           </a:prstGeom>
           <a:solidFill>
-            <a:srgbClr val="172043"/>
+            <a:srgbClr val="1E293B"/>
           </a:solidFill>
           <a:ln w="19050">
             <a:solidFill>
-              <a:srgbClr val="00FF87"/>
+              <a:srgbClr val="22C55E"/>
             </a:solidFill>
           </a:ln>
         </p:spPr>
@@ -3250,7 +3250,7 @@
               </a:defRPr>
             </a:pPr>
             <a:r>
-              <a:t>🔑 0-Friction JoyID Passkeys</a:t>
+              <a:t>JoyID Passkeys</a:t>
             </a:r>
           </a:p>
         </p:txBody>
@@ -3264,17 +3264,17 @@
         <p:spPr>
           <a:xfrm>
             <a:off x="3474720" y="4389120"/>
-            <a:ext cx="2377440" cy="822960"/>
+            <a:ext cx="2377440" cy="731520"/>
           </a:xfrm>
           <a:prstGeom prst="roundRect">
             <a:avLst/>
           </a:prstGeom>
           <a:solidFill>
-            <a:srgbClr val="172043"/>
+            <a:srgbClr val="1E293B"/>
           </a:solidFill>
           <a:ln w="19050">
             <a:solidFill>
-              <a:srgbClr val="00FF87"/>
+              <a:srgbClr val="22C55E"/>
             </a:solidFill>
           </a:ln>
         </p:spPr>
@@ -3304,7 +3304,7 @@
               </a:defRPr>
             </a:pPr>
             <a:r>
-              <a:t>📜 Spore DOB Passports</a:t>
+              <a:t>Spore DOB Passports</a:t>
             </a:r>
           </a:p>
         </p:txBody>
@@ -3318,17 +3318,17 @@
         <p:spPr>
           <a:xfrm>
             <a:off x="6035040" y="4389120"/>
-            <a:ext cx="2377440" cy="822960"/>
+            <a:ext cx="2377440" cy="731520"/>
           </a:xfrm>
           <a:prstGeom prst="roundRect">
             <a:avLst/>
           </a:prstGeom>
           <a:solidFill>
-            <a:srgbClr val="172043"/>
+            <a:srgbClr val="1E293B"/>
           </a:solidFill>
           <a:ln w="19050">
             <a:solidFill>
-              <a:srgbClr val="00FF87"/>
+              <a:srgbClr val="22C55E"/>
             </a:solidFill>
           </a:ln>
         </p:spPr>
@@ -3358,7 +3358,7 @@
               </a:defRPr>
             </a:pPr>
             <a:r>
-              <a:t>🛡️ Safety Recall Check</a:t>
+              <a:t>Safety Recall Check</a:t>
             </a:r>
           </a:p>
         </p:txBody>
@@ -3372,17 +3372,17 @@
         <p:spPr>
           <a:xfrm>
             <a:off x="8595360" y="4389120"/>
-            <a:ext cx="2377440" cy="822960"/>
+            <a:ext cx="2377440" cy="731520"/>
           </a:xfrm>
           <a:prstGeom prst="roundRect">
             <a:avLst/>
           </a:prstGeom>
           <a:solidFill>
-            <a:srgbClr val="172043"/>
+            <a:srgbClr val="1E293B"/>
           </a:solidFill>
           <a:ln w="19050">
             <a:solidFill>
-              <a:srgbClr val="00FF87"/>
+              <a:srgbClr val="22C55E"/>
             </a:solidFill>
           </a:ln>
         </p:spPr>
@@ -3412,7 +3412,7 @@
               </a:defRPr>
             </a:pPr>
             <a:r>
-              <a:t>📱 QR Meetup Handover</a:t>
+              <a:t>QR Meetup Settlement</a:t>
             </a:r>
           </a:p>
         </p:txBody>
@@ -3447,7 +3447,7 @@
               </a:defRPr>
             </a:pPr>
             <a:r>
-              <a:t>Nervos CKB Hackathon Presentation · August 2026</a:t>
+              <a:t>Nervos CKB Presentation · August 2026</a:t>
             </a:r>
           </a:p>
         </p:txBody>
@@ -3485,7 +3485,7 @@
             <a:avLst/>
           </a:prstGeom>
           <a:solidFill>
-            <a:srgbClr val="F8FAFC"/>
+            <a:srgbClr val="0F172A"/>
           </a:solidFill>
           <a:ln>
             <a:noFill/>
@@ -3522,7 +3522,7 @@
         <p:spPr>
           <a:xfrm>
             <a:off x="914400" y="548640"/>
-            <a:ext cx="10362895" cy="914400"/>
+            <a:ext cx="10362895" cy="731520"/>
           </a:xfrm>
           <a:prstGeom prst="rect">
             <a:avLst/>
@@ -3538,7 +3538,7 @@
             <a:pPr>
               <a:defRPr sz="3600" b="1">
                 <a:solidFill>
-                  <a:srgbClr val="0A1128"/>
+                  <a:srgbClr val="22C55E"/>
                 </a:solidFill>
               </a:defRPr>
             </a:pPr>
@@ -3557,17 +3557,17 @@
         <p:spPr>
           <a:xfrm>
             <a:off x="914400" y="1463040"/>
-            <a:ext cx="4937760" cy="4754880"/>
+            <a:ext cx="4937760" cy="4572000"/>
           </a:xfrm>
           <a:prstGeom prst="roundRect">
             <a:avLst/>
           </a:prstGeom>
           <a:solidFill>
-            <a:srgbClr val="FEF2F2"/>
+            <a:srgbClr val="1C1018"/>
           </a:solidFill>
           <a:ln w="19050">
             <a:solidFill>
-              <a:srgbClr val="F87171"/>
+              <a:srgbClr val="EF4444"/>
             </a:solidFill>
           </a:ln>
         </p:spPr>
@@ -3590,74 +3590,59 @@
           <a:lstStyle/>
           <a:p>
             <a:pPr algn="ctr">
-              <a:defRPr sz="1800" b="1">
-                <a:solidFill>
-                  <a:srgbClr val="B91C1C"/>
-                </a:solidFill>
-              </a:defRPr>
-            </a:pPr>
-            <a:r>
-              <a:t>❌ The Problem</a:t>
+              <a:defRPr sz="2000" b="1">
+                <a:solidFill>
+                  <a:srgbClr val="F87171"/>
+                </a:solidFill>
+              </a:defRPr>
+            </a:pPr>
+            <a:r>
+              <a:t>The Parent Challenge</a:t>
             </a:r>
           </a:p>
           <a:p>
             <a:pPr>
               <a:spcBef>
-                <a:spcPts val="400"/>
+                <a:spcPts val="2000"/>
               </a:spcBef>
-              <a:defRPr sz="1100">
-                <a:solidFill>
-                  <a:srgbClr val="0F172A"/>
-                </a:solidFill>
-              </a:defRPr>
-            </a:pPr>
-            <a:r>
-              <a:t>• High Expense: Kids outgrow toys rapidly, creating continuous financial pressure.</a:t>
+              <a:defRPr sz="1300">
+                <a:solidFill>
+                  <a:srgbClr val="FFFFFF"/>
+                </a:solidFill>
+              </a:defRPr>
+            </a:pPr>
+            <a:r>
+              <a:t>High Expense: Rapid outgrowing of toys creates constant recurring costs.</a:t>
             </a:r>
           </a:p>
           <a:p>
             <a:pPr>
               <a:spcBef>
-                <a:spcPts val="400"/>
+                <a:spcPts val="2000"/>
               </a:spcBef>
-              <a:defRPr sz="1100">
-                <a:solidFill>
-                  <a:srgbClr val="0F172A"/>
-                </a:solidFill>
-              </a:defRPr>
-            </a:pPr>
-            <a:r>
-              <a:t>• Lack of Local Trust: In-person park/coffee shop meetups lack escrow security.</a:t>
+              <a:defRPr sz="1300">
+                <a:solidFill>
+                  <a:srgbClr val="FFFFFF"/>
+                </a:solidFill>
+              </a:defRPr>
+            </a:pPr>
+            <a:r>
+              <a:t>Lack of Trust: Local in-person meetups lack escrow security and trade guarantees.</a:t>
             </a:r>
           </a:p>
           <a:p>
             <a:pPr>
               <a:spcBef>
-                <a:spcPts val="400"/>
+                <a:spcPts val="2000"/>
               </a:spcBef>
-              <a:defRPr sz="1100">
-                <a:solidFill>
-                  <a:srgbClr val="0F172A"/>
-                </a:solidFill>
-              </a:defRPr>
-            </a:pPr>
-            <a:r>
-              <a:t>• Safety &amp; Recall Risks: Parents unknowingly trade toys recalled by safety agencies.</a:t>
-            </a:r>
-          </a:p>
-          <a:p>
-            <a:pPr>
-              <a:spcBef>
-                <a:spcPts val="400"/>
-              </a:spcBef>
-              <a:defRPr sz="1100">
-                <a:solidFill>
-                  <a:srgbClr val="0F172A"/>
-                </a:solidFill>
-              </a:defRPr>
-            </a:pPr>
-            <a:r>
-              <a:t>• Overpricing Confusion: Sellers struggle to evaluate second-hand market value.</a:t>
+              <a:defRPr sz="1300">
+                <a:solidFill>
+                  <a:srgbClr val="FFFFFF"/>
+                </a:solidFill>
+              </a:defRPr>
+            </a:pPr>
+            <a:r>
+              <a:t>Safety Risks: Recalled toys circulate unchecked on general secondhand sites.</a:t>
             </a:r>
           </a:p>
         </p:txBody>
@@ -3671,17 +3656,17 @@
         <p:spPr>
           <a:xfrm>
             <a:off x="6309360" y="1463040"/>
-            <a:ext cx="4937760" cy="4754880"/>
+            <a:ext cx="4937760" cy="4572000"/>
           </a:xfrm>
           <a:prstGeom prst="roundRect">
             <a:avLst/>
           </a:prstGeom>
           <a:solidFill>
-            <a:srgbClr val="0A1128"/>
+            <a:srgbClr val="0D2820"/>
           </a:solidFill>
-          <a:ln w="25400">
+          <a:ln w="19050">
             <a:solidFill>
-              <a:srgbClr val="00FF87"/>
+              <a:srgbClr val="22C55E"/>
             </a:solidFill>
           </a:ln>
         </p:spPr>
@@ -3704,89 +3689,59 @@
           <a:lstStyle/>
           <a:p>
             <a:pPr algn="ctr">
-              <a:defRPr sz="1800" b="1">
-                <a:solidFill>
-                  <a:srgbClr val="00FF87"/>
-                </a:solidFill>
-              </a:defRPr>
-            </a:pPr>
-            <a:r>
-              <a:t>✅ The ToyTrade CKB Solution</a:t>
+              <a:defRPr sz="2000" b="1">
+                <a:solidFill>
+                  <a:srgbClr val="22C55E"/>
+                </a:solidFill>
+              </a:defRPr>
+            </a:pPr>
+            <a:r>
+              <a:t>The CKB Solution</a:t>
             </a:r>
           </a:p>
           <a:p>
             <a:pPr>
               <a:spcBef>
-                <a:spcPts val="400"/>
+                <a:spcPts val="2000"/>
               </a:spcBef>
-              <a:defRPr sz="1100">
+              <a:defRPr sz="1300">
                 <a:solidFill>
                   <a:srgbClr val="FFFFFF"/>
                 </a:solidFill>
               </a:defRPr>
             </a:pPr>
             <a:r>
-              <a:t>• 2-of-2 CKB Smart Contract Escrow: Locks payments until delivery is verified.</a:t>
+              <a:t>2-of-2 CKB Smart Contract: Trustless escrow releases payment only upon verified delivery.</a:t>
             </a:r>
           </a:p>
           <a:p>
             <a:pPr>
               <a:spcBef>
-                <a:spcPts val="400"/>
+                <a:spcPts val="2000"/>
               </a:spcBef>
-              <a:defRPr sz="1100">
+              <a:defRPr sz="1300">
                 <a:solidFill>
                   <a:srgbClr val="FFFFFF"/>
                 </a:solidFill>
               </a:defRPr>
             </a:pPr>
             <a:r>
-              <a:t>• 📱 QR Meetup Handover: Instant 2-second dual confirmation at local meetups.</a:t>
+              <a:t>Automated Safety Recall Check: Live screening against CPSC and EU databases during listing.</a:t>
             </a:r>
           </a:p>
           <a:p>
             <a:pPr>
               <a:spcBef>
-                <a:spcPts val="400"/>
+                <a:spcPts val="2000"/>
               </a:spcBef>
-              <a:defRPr sz="1100">
+              <a:defRPr sz="1300">
                 <a:solidFill>
                   <a:srgbClr val="FFFFFF"/>
                 </a:solidFill>
               </a:defRPr>
             </a:pPr>
             <a:r>
-              <a:t>• 🛡️ Safety Recall Auto-Check: Queries CPSC &amp; EU databases live to block recalled toys.</a:t>
-            </a:r>
-          </a:p>
-          <a:p>
-            <a:pPr>
-              <a:spcBef>
-                <a:spcPts val="400"/>
-              </a:spcBef>
-              <a:defRPr sz="1100">
-                <a:solidFill>
-                  <a:srgbClr val="FFFFFF"/>
-                </a:solidFill>
-              </a:defRPr>
-            </a:pPr>
-            <a:r>
-              <a:t>• 📜 Spore DOB Toy Passport: On-chain provenance recording condition history.</a:t>
-            </a:r>
-          </a:p>
-          <a:p>
-            <a:pPr>
-              <a:spcBef>
-                <a:spcPts val="400"/>
-              </a:spcBef>
-              <a:defRPr sz="1100">
-                <a:solidFill>
-                  <a:srgbClr val="FFFFFF"/>
-                </a:solidFill>
-              </a:defRPr>
-            </a:pPr>
-            <a:r>
-              <a:t>• 🔑 JoyID Passkeys: Log in with FaceID/Fingerprint — 0 crypto friction for parents.</a:t>
+              <a:t>Spore DOB Passports &amp; Passkeys: On-chain provenance with zero-friction JoyID biometric login.</a:t>
             </a:r>
           </a:p>
         </p:txBody>
@@ -3824,7 +3779,7 @@
             <a:avLst/>
           </a:prstGeom>
           <a:solidFill>
-            <a:srgbClr val="F8FAFC"/>
+            <a:srgbClr val="0F172A"/>
           </a:solidFill>
           <a:ln>
             <a:noFill/>
@@ -3861,7 +3816,7 @@
         <p:spPr>
           <a:xfrm>
             <a:off x="914400" y="548640"/>
-            <a:ext cx="10362895" cy="914400"/>
+            <a:ext cx="10362895" cy="731520"/>
           </a:xfrm>
           <a:prstGeom prst="rect">
             <a:avLst/>
@@ -3877,7 +3832,7 @@
             <a:pPr>
               <a:defRPr sz="3600" b="1">
                 <a:solidFill>
-                  <a:srgbClr val="0A1128"/>
+                  <a:srgbClr val="22C55E"/>
                 </a:solidFill>
               </a:defRPr>
             </a:pPr>
@@ -3895,18 +3850,18 @@
         </p:nvSpPr>
         <p:spPr>
           <a:xfrm>
-            <a:off x="914400" y="1645920"/>
-            <a:ext cx="3200400" cy="4389120"/>
+            <a:off x="914400" y="1463040"/>
+            <a:ext cx="3200400" cy="4572000"/>
           </a:xfrm>
           <a:prstGeom prst="roundRect">
             <a:avLst/>
           </a:prstGeom>
           <a:solidFill>
-            <a:srgbClr val="FFFFFF"/>
+            <a:srgbClr val="1E293B"/>
           </a:solidFill>
           <a:ln w="12700">
             <a:solidFill>
-              <a:srgbClr val="E2E8F0"/>
+              <a:srgbClr val="334155"/>
             </a:solidFill>
           </a:ln>
         </p:spPr>
@@ -3931,18 +3886,18 @@
             <a:pPr algn="ctr">
               <a:defRPr sz="2000" b="1">
                 <a:solidFill>
-                  <a:srgbClr val="0A1128"/>
-                </a:solidFill>
-              </a:defRPr>
-            </a:pPr>
-            <a:r>
-              <a:t>① Seller's Price</a:t>
+                  <a:srgbClr val="FFFFFF"/>
+                </a:solidFill>
+              </a:defRPr>
+            </a:pPr>
+            <a:r>
+              <a:t>1. Seller Price</a:t>
             </a:r>
           </a:p>
           <a:p>
             <a:pPr>
               <a:spcBef>
-                <a:spcPts val="600"/>
+                <a:spcPts val="800"/>
               </a:spcBef>
               <a:defRPr sz="1300" b="1">
                 <a:solidFill>
@@ -3951,22 +3906,22 @@
               </a:defRPr>
             </a:pPr>
             <a:r>
-              <a:t>Local Fiat Choice (£ / ₫)</a:t>
+              <a:t>Local Fiat Choice (GBP / VND)</a:t>
             </a:r>
           </a:p>
           <a:p>
             <a:pPr>
               <a:spcBef>
-                <a:spcPts val="1400"/>
+                <a:spcPts val="2000"/>
               </a:spcBef>
               <a:defRPr sz="1300">
                 <a:solidFill>
-                  <a:srgbClr val="0F172A"/>
-                </a:solidFill>
-              </a:defRPr>
-            </a:pPr>
-            <a:r>
-              <a:t>Set directly by parents in their local currency (GBP or VND). Keeps pricing natural, familiar, and easy for non-crypto parents.</a:t>
+                  <a:srgbClr val="FFFFFF"/>
+                </a:solidFill>
+              </a:defRPr>
+            </a:pPr>
+            <a:r>
+              <a:t>Set directly by parents in their local fiat currency. Keeps pricing natural, intuitive, and simple for non-crypto users.</a:t>
             </a:r>
           </a:p>
         </p:txBody>
@@ -3979,18 +3934,18 @@
         </p:nvSpPr>
         <p:spPr>
           <a:xfrm>
-            <a:off x="4480560" y="1645920"/>
-            <a:ext cx="3200400" cy="4389120"/>
+            <a:off x="4480560" y="1463040"/>
+            <a:ext cx="3200400" cy="4572000"/>
           </a:xfrm>
           <a:prstGeom prst="roundRect">
             <a:avLst/>
           </a:prstGeom>
           <a:solidFill>
-            <a:srgbClr val="FFFFFF"/>
+            <a:srgbClr val="1E293B"/>
           </a:solidFill>
           <a:ln w="12700">
             <a:solidFill>
-              <a:srgbClr val="E2E8F0"/>
+              <a:srgbClr val="334155"/>
             </a:solidFill>
           </a:ln>
         </p:spPr>
@@ -4015,18 +3970,18 @@
             <a:pPr algn="ctr">
               <a:defRPr sz="2000" b="1">
                 <a:solidFill>
-                  <a:srgbClr val="0A1128"/>
-                </a:solidFill>
-              </a:defRPr>
-            </a:pPr>
-            <a:r>
-              <a:t>② Market Reference</a:t>
+                  <a:srgbClr val="FFFFFF"/>
+                </a:solidFill>
+              </a:defRPr>
+            </a:pPr>
+            <a:r>
+              <a:t>2. Market Reference</a:t>
             </a:r>
           </a:p>
           <a:p>
             <a:pPr>
               <a:spcBef>
-                <a:spcPts val="600"/>
+                <a:spcPts val="800"/>
               </a:spcBef>
               <a:defRPr sz="1300" b="1">
                 <a:solidFill>
@@ -4035,22 +3990,22 @@
               </a:defRPr>
             </a:pPr>
             <a:r>
-              <a:t>Google Lens Visual Match</a:t>
+              <a:t>Automated Google Lens Match</a:t>
             </a:r>
           </a:p>
           <a:p>
             <a:pPr>
               <a:spcBef>
-                <a:spcPts val="1400"/>
+                <a:spcPts val="2000"/>
               </a:spcBef>
               <a:defRPr sz="1300">
                 <a:solidFill>
-                  <a:srgbClr val="0F172A"/>
-                </a:solidFill>
-              </a:defRPr>
-            </a:pPr>
-            <a:r>
-              <a:t>Extracted automatically via Google Lens (SerpApi) image search. Protects parent buyers from wildly overpriced second-hand listings.</a:t>
+                  <a:srgbClr val="FFFFFF"/>
+                </a:solidFill>
+              </a:defRPr>
+            </a:pPr>
+            <a:r>
+              <a:t>Extracted automatically via Google Lens visual search to protect buyers against overpriced secondhand listings.</a:t>
             </a:r>
           </a:p>
         </p:txBody>
@@ -4063,18 +4018,18 @@
         </p:nvSpPr>
         <p:spPr>
           <a:xfrm>
-            <a:off x="8046720" y="1645920"/>
-            <a:ext cx="3200400" cy="4389120"/>
+            <a:off x="8046720" y="1463040"/>
+            <a:ext cx="3200400" cy="4572000"/>
           </a:xfrm>
           <a:prstGeom prst="roundRect">
             <a:avLst/>
           </a:prstGeom>
           <a:solidFill>
-            <a:srgbClr val="0A1128"/>
+            <a:srgbClr val="1E293B"/>
           </a:solidFill>
           <a:ln w="25400">
             <a:solidFill>
-              <a:srgbClr val="00FF87"/>
+              <a:srgbClr val="22C55E"/>
             </a:solidFill>
           </a:ln>
         </p:spPr>
@@ -4099,33 +4054,33 @@
             <a:pPr algn="ctr">
               <a:defRPr sz="2000" b="1">
                 <a:solidFill>
-                  <a:srgbClr val="00FF87"/>
-                </a:solidFill>
-              </a:defRPr>
-            </a:pPr>
-            <a:r>
-              <a:t>③ CKB Equivalent</a:t>
+                  <a:srgbClr val="22C55E"/>
+                </a:solidFill>
+              </a:defRPr>
+            </a:pPr>
+            <a:r>
+              <a:t>3. CKB Settlement</a:t>
             </a:r>
           </a:p>
           <a:p>
             <a:pPr>
               <a:spcBef>
-                <a:spcPts val="600"/>
+                <a:spcPts val="800"/>
               </a:spcBef>
               <a:defRPr sz="1300" b="1">
                 <a:solidFill>
-                  <a:srgbClr val="60EFFF"/>
-                </a:solidFill>
-              </a:defRPr>
-            </a:pPr>
-            <a:r>
-              <a:t>Real-Time Exchange Settle</a:t>
+                  <a:srgbClr val="0EA5E9"/>
+                </a:solidFill>
+              </a:defRPr>
+            </a:pPr>
+            <a:r>
+              <a:t>Real-Time Exchange Rate</a:t>
             </a:r>
           </a:p>
           <a:p>
             <a:pPr>
               <a:spcBef>
-                <a:spcPts val="1400"/>
+                <a:spcPts val="2000"/>
               </a:spcBef>
               <a:defRPr sz="1300">
                 <a:solidFill>
@@ -4134,7 +4089,7 @@
               </a:defRPr>
             </a:pPr>
             <a:r>
-              <a:t>Calculated dynamically from CoinGecko feeds. Locked into the CKB Escrow Smart Contract Cell upon trade initiation.</a:t>
+              <a:t>Calculated dynamically from CoinGecko feeds and locked into the CKB Escrow Smart Contract Cell upon trade creation.</a:t>
             </a:r>
           </a:p>
         </p:txBody>
@@ -4172,7 +4127,7 @@
             <a:avLst/>
           </a:prstGeom>
           <a:solidFill>
-            <a:srgbClr val="F8FAFC"/>
+            <a:srgbClr val="0F172A"/>
           </a:solidFill>
           <a:ln>
             <a:noFill/>
@@ -4209,7 +4164,7 @@
         <p:spPr>
           <a:xfrm>
             <a:off x="914400" y="548640"/>
-            <a:ext cx="10362895" cy="914400"/>
+            <a:ext cx="10362895" cy="731520"/>
           </a:xfrm>
           <a:prstGeom prst="rect">
             <a:avLst/>
@@ -4225,7 +4180,7 @@
             <a:pPr>
               <a:defRPr sz="3600" b="1">
                 <a:solidFill>
-                  <a:srgbClr val="0A1128"/>
+                  <a:srgbClr val="22C55E"/>
                 </a:solidFill>
               </a:defRPr>
             </a:pPr>
@@ -4243,14 +4198,14 @@
         </p:nvSpPr>
         <p:spPr>
           <a:xfrm>
-            <a:off x="914400" y="1645920"/>
-            <a:ext cx="2423160" cy="3474720"/>
+            <a:off x="914400" y="1463040"/>
+            <a:ext cx="2423160" cy="3657600"/>
           </a:xfrm>
           <a:prstGeom prst="roundRect">
             <a:avLst/>
           </a:prstGeom>
           <a:solidFill>
-            <a:srgbClr val="0A1128"/>
+            <a:srgbClr val="1E293B"/>
           </a:solidFill>
           <a:ln w="12700">
             <a:solidFill>
@@ -4279,7 +4234,7 @@
             <a:pPr algn="ctr">
               <a:defRPr sz="1700" b="1">
                 <a:solidFill>
-                  <a:srgbClr val="60EFFF"/>
+                  <a:srgbClr val="0EA5E9"/>
                 </a:solidFill>
               </a:defRPr>
             </a:pPr>
@@ -4290,16 +4245,16 @@
           <a:p>
             <a:pPr>
               <a:spcBef>
-                <a:spcPts val="1200"/>
+                <a:spcPts val="1600"/>
               </a:spcBef>
-              <a:defRPr sz="1200">
+              <a:defRPr sz="1300">
                 <a:solidFill>
                   <a:srgbClr val="FFFFFF"/>
                 </a:solidFill>
               </a:defRPr>
             </a:pPr>
             <a:r>
-              <a:t>Buyer connects via JoyID passkey and locks CKB equivalent into the custom Escrow Lock Cell.</a:t>
+              <a:t>Buyer connects via JoyID passkey and locks CKB equivalent into the Escrow Lock Cell.</a:t>
             </a:r>
           </a:p>
         </p:txBody>
@@ -4312,14 +4267,14 @@
         </p:nvSpPr>
         <p:spPr>
           <a:xfrm>
-            <a:off x="3557016" y="1645920"/>
-            <a:ext cx="2423160" cy="3474720"/>
+            <a:off x="3557016" y="1463040"/>
+            <a:ext cx="2423160" cy="3657600"/>
           </a:xfrm>
           <a:prstGeom prst="roundRect">
             <a:avLst/>
           </a:prstGeom>
           <a:solidFill>
-            <a:srgbClr val="0A1128"/>
+            <a:srgbClr val="1E293B"/>
           </a:solidFill>
           <a:ln w="12700">
             <a:solidFill>
@@ -4348,7 +4303,7 @@
             <a:pPr algn="ctr">
               <a:defRPr sz="1700" b="1">
                 <a:solidFill>
-                  <a:srgbClr val="60EFFF"/>
+                  <a:srgbClr val="0EA5E9"/>
                 </a:solidFill>
               </a:defRPr>
             </a:pPr>
@@ -4359,16 +4314,16 @@
           <a:p>
             <a:pPr>
               <a:spcBef>
-                <a:spcPts val="1200"/>
+                <a:spcPts val="1600"/>
               </a:spcBef>
-              <a:defRPr sz="1200">
+              <a:defRPr sz="1300">
                 <a:solidFill>
                   <a:srgbClr val="FFFFFF"/>
                 </a:solidFill>
               </a:defRPr>
             </a:pPr>
             <a:r>
-              <a:t>Automated Safety Recall check validates toy model against official hazard catalogs.</a:t>
+              <a:t>Automated recall screening validates toy model against official safety hazard catalogs.</a:t>
             </a:r>
           </a:p>
         </p:txBody>
@@ -4381,18 +4336,18 @@
         </p:nvSpPr>
         <p:spPr>
           <a:xfrm>
-            <a:off x="6199632" y="1645920"/>
-            <a:ext cx="2423160" cy="3474720"/>
+            <a:off x="6199632" y="1463040"/>
+            <a:ext cx="2423160" cy="3657600"/>
           </a:xfrm>
           <a:prstGeom prst="roundRect">
             <a:avLst/>
           </a:prstGeom>
           <a:solidFill>
-            <a:srgbClr val="0A1128"/>
+            <a:srgbClr val="1E293B"/>
           </a:solidFill>
           <a:ln w="25400">
             <a:solidFill>
-              <a:srgbClr val="00FF87"/>
+              <a:srgbClr val="22C55E"/>
             </a:solidFill>
           </a:ln>
         </p:spPr>
@@ -4417,7 +4372,7 @@
             <a:pPr algn="ctr">
               <a:defRPr sz="1700" b="1">
                 <a:solidFill>
-                  <a:srgbClr val="00FF87"/>
+                  <a:srgbClr val="22C55E"/>
                 </a:solidFill>
               </a:defRPr>
             </a:pPr>
@@ -4428,16 +4383,16 @@
           <a:p>
             <a:pPr>
               <a:spcBef>
-                <a:spcPts val="1200"/>
+                <a:spcPts val="1600"/>
               </a:spcBef>
-              <a:defRPr sz="1200">
+              <a:defRPr sz="1300">
                 <a:solidFill>
                   <a:srgbClr val="FFFFFF"/>
                 </a:solidFill>
               </a:defRPr>
             </a:pPr>
             <a:r>
-              <a:t>Buyer displays 1-time dynamic QR code at park/coffee shop meetup. Seller scans to confirm.</a:t>
+              <a:t>Buyer presents 1-time dynamic QR code at local meetup. Seller scans to confirm handover.</a:t>
             </a:r>
           </a:p>
         </p:txBody>
@@ -4450,14 +4405,14 @@
         </p:nvSpPr>
         <p:spPr>
           <a:xfrm>
-            <a:off x="8842248" y="1645920"/>
-            <a:ext cx="2423160" cy="3474720"/>
+            <a:off x="8842248" y="1463040"/>
+            <a:ext cx="2423160" cy="3657600"/>
           </a:xfrm>
           <a:prstGeom prst="roundRect">
             <a:avLst/>
           </a:prstGeom>
           <a:solidFill>
-            <a:srgbClr val="0A1128"/>
+            <a:srgbClr val="1E293B"/>
           </a:solidFill>
           <a:ln w="12700">
             <a:solidFill>
@@ -4486,27 +4441,27 @@
             <a:pPr algn="ctr">
               <a:defRPr sz="1700" b="1">
                 <a:solidFill>
-                  <a:srgbClr val="60EFFF"/>
-                </a:solidFill>
-              </a:defRPr>
-            </a:pPr>
-            <a:r>
-              <a:t>4. Instant Settle</a:t>
+                  <a:srgbClr val="0EA5E9"/>
+                </a:solidFill>
+              </a:defRPr>
+            </a:pPr>
+            <a:r>
+              <a:t>4. Settlement</a:t>
             </a:r>
           </a:p>
           <a:p>
             <a:pPr>
               <a:spcBef>
-                <a:spcPts val="1200"/>
+                <a:spcPts val="1600"/>
               </a:spcBef>
-              <a:defRPr sz="1200">
+              <a:defRPr sz="1300">
                 <a:solidFill>
                   <a:srgbClr val="FFFFFF"/>
                 </a:solidFill>
               </a:defRPr>
             </a:pPr>
             <a:r>
-              <a:t>Dual confirmation releases CKB to seller &amp; transfers Spore DOB Toy Passport to buyer.</a:t>
+              <a:t>Dual confirmation releases CKB payment to seller and transfers Spore DOB Passport to buyer.</a:t>
             </a:r>
           </a:p>
         </p:txBody>
@@ -4519,14 +4474,14 @@
         </p:nvSpPr>
         <p:spPr>
           <a:xfrm>
-            <a:off x="914400" y="5303520"/>
-            <a:ext cx="10362895" cy="822960"/>
+            <a:off x="914400" y="5394960"/>
+            <a:ext cx="10362895" cy="731520"/>
           </a:xfrm>
           <a:prstGeom prst="roundRect">
             <a:avLst/>
           </a:prstGeom>
           <a:solidFill>
-            <a:srgbClr val="FEF3C7"/>
+            <a:srgbClr val="1E293B"/>
           </a:solidFill>
           <a:ln w="19050">
             <a:solidFill>
@@ -4555,12 +4510,12 @@
             <a:pPr algn="ctr">
               <a:defRPr sz="1300" b="1">
                 <a:solidFill>
-                  <a:srgbClr val="92400E"/>
-                </a:solidFill>
-              </a:defRPr>
-            </a:pPr>
-            <a:r>
-              <a:t>🛡️ Timeout Refund Safeguard: 7-Day automatic lock expiration allows the buyer to reclaim full CKB funds if the trade is canceled or unconfirmed.</a:t>
+                  <a:srgbClr val="FBBF24"/>
+                </a:solidFill>
+              </a:defRPr>
+            </a:pPr>
+            <a:r>
+              <a:t>Timeout Refund Safeguard: 7-Day automatic lock expiration enables buyers to reclaim CKB funds if trades stall.</a:t>
             </a:r>
           </a:p>
         </p:txBody>
@@ -4598,7 +4553,7 @@
             <a:avLst/>
           </a:prstGeom>
           <a:solidFill>
-            <a:srgbClr val="F8FAFC"/>
+            <a:srgbClr val="0F172A"/>
           </a:solidFill>
           <a:ln>
             <a:noFill/>
@@ -4635,7 +4590,7 @@
         <p:spPr>
           <a:xfrm>
             <a:off x="914400" y="548640"/>
-            <a:ext cx="10362895" cy="914400"/>
+            <a:ext cx="10362895" cy="731520"/>
           </a:xfrm>
           <a:prstGeom prst="rect">
             <a:avLst/>
@@ -4651,7 +4606,7 @@
             <a:pPr>
               <a:defRPr sz="3600" b="1">
                 <a:solidFill>
-                  <a:srgbClr val="0A1128"/>
+                  <a:srgbClr val="22C55E"/>
                 </a:solidFill>
               </a:defRPr>
             </a:pPr>
@@ -4669,14 +4624,14 @@
         </p:nvSpPr>
         <p:spPr>
           <a:xfrm>
-            <a:off x="914400" y="1645920"/>
-            <a:ext cx="3200400" cy="4389120"/>
+            <a:off x="914400" y="1463040"/>
+            <a:ext cx="3200400" cy="4572000"/>
           </a:xfrm>
           <a:prstGeom prst="roundRect">
             <a:avLst/>
           </a:prstGeom>
           <a:solidFill>
-            <a:srgbClr val="0A1128"/>
+            <a:srgbClr val="1E293B"/>
           </a:solidFill>
           <a:ln w="12700">
             <a:solidFill>
@@ -4705,18 +4660,18 @@
             <a:pPr algn="ctr">
               <a:defRPr sz="1700" b="1">
                 <a:solidFill>
-                  <a:srgbClr val="00FF87"/>
-                </a:solidFill>
-              </a:defRPr>
-            </a:pPr>
-            <a:r>
-              <a:t>🛡️ Safety Recall Checker</a:t>
+                  <a:srgbClr val="22C55E"/>
+                </a:solidFill>
+              </a:defRPr>
+            </a:pPr>
+            <a:r>
+              <a:t>Safety Recall Checker</a:t>
             </a:r>
           </a:p>
           <a:p>
             <a:pPr>
               <a:spcBef>
-                <a:spcPts val="1000"/>
+                <a:spcPts val="1600"/>
               </a:spcBef>
               <a:defRPr sz="1300">
                 <a:solidFill>
@@ -4725,13 +4680,13 @@
               </a:defRPr>
             </a:pPr>
             <a:r>
-              <a:t>• Real-time query against official CPSC &amp; EU Safety Gate databases.</a:t>
+              <a:t>Real-time database query against official CPSC and EU Safety Gate hazard lists.</a:t>
             </a:r>
           </a:p>
           <a:p>
             <a:pPr>
               <a:spcBef>
-                <a:spcPts val="1000"/>
+                <a:spcPts val="1600"/>
               </a:spcBef>
               <a:defRPr sz="1300">
                 <a:solidFill>
@@ -4740,13 +4695,13 @@
               </a:defRPr>
             </a:pPr>
             <a:r>
-              <a:t>• Live alert banner displays while sellers type toy names.</a:t>
+              <a:t>Live warning alerts inform sellers before listing submission.</a:t>
             </a:r>
           </a:p>
           <a:p>
             <a:pPr>
               <a:spcBef>
-                <a:spcPts val="1000"/>
+                <a:spcPts val="1600"/>
               </a:spcBef>
               <a:defRPr sz="1300">
                 <a:solidFill>
@@ -4755,7 +4710,7 @@
               </a:defRPr>
             </a:pPr>
             <a:r>
-              <a:t>• Prevents unsafe or recalled toys from entering the marketplace.</a:t>
+              <a:t>Prevents hazardous or recalled toys from entering trade channels.</a:t>
             </a:r>
           </a:p>
         </p:txBody>
@@ -4768,14 +4723,14 @@
         </p:nvSpPr>
         <p:spPr>
           <a:xfrm>
-            <a:off x="4480560" y="1645920"/>
-            <a:ext cx="3200400" cy="4389120"/>
+            <a:off x="4480560" y="1463040"/>
+            <a:ext cx="3200400" cy="4572000"/>
           </a:xfrm>
           <a:prstGeom prst="roundRect">
             <a:avLst/>
           </a:prstGeom>
           <a:solidFill>
-            <a:srgbClr val="0A1128"/>
+            <a:srgbClr val="1E293B"/>
           </a:solidFill>
           <a:ln w="12700">
             <a:solidFill>
@@ -4804,18 +4759,18 @@
             <a:pPr algn="ctr">
               <a:defRPr sz="1700" b="1">
                 <a:solidFill>
-                  <a:srgbClr val="60EFFF"/>
-                </a:solidFill>
-              </a:defRPr>
-            </a:pPr>
-            <a:r>
-              <a:t>📜 Spore DOB Passport</a:t>
+                  <a:srgbClr val="0EA5E9"/>
+                </a:solidFill>
+              </a:defRPr>
+            </a:pPr>
+            <a:r>
+              <a:t>Spore DOB Passport</a:t>
             </a:r>
           </a:p>
           <a:p>
             <a:pPr>
               <a:spcBef>
-                <a:spcPts val="1000"/>
+                <a:spcPts val="1600"/>
               </a:spcBef>
               <a:defRPr sz="1300">
                 <a:solidFill>
@@ -4824,13 +4779,13 @@
               </a:defRPr>
             </a:pPr>
             <a:r>
-              <a:t>• On-chain digital passport minted directly on Nervos CKB cells.</a:t>
+              <a:t>On-chain digital passport minted directly on Nervos CKB cells.</a:t>
             </a:r>
           </a:p>
           <a:p>
             <a:pPr>
               <a:spcBef>
-                <a:spcPts val="1000"/>
+                <a:spcPts val="1600"/>
               </a:spcBef>
               <a:defRPr sz="1300">
                 <a:solidFill>
@@ -4839,13 +4794,13 @@
               </a:defRPr>
             </a:pPr>
             <a:r>
-              <a:t>• Records multi-owner condition history, photo stamps, &amp; parent reviews.</a:t>
+              <a:t>Tracks multi-owner condition history, photo stamps, and parent reviews.</a:t>
             </a:r>
           </a:p>
           <a:p>
             <a:pPr>
               <a:spcBef>
-                <a:spcPts val="1000"/>
+                <a:spcPts val="1600"/>
               </a:spcBef>
               <a:defRPr sz="1300">
                 <a:solidFill>
@@ -4854,7 +4809,7 @@
               </a:defRPr>
             </a:pPr>
             <a:r>
-              <a:t>• Backed by underlying CKB storage capacity ('melt' value).</a:t>
+              <a:t>Backed by underlying CKB storage capacity ('melt' value).</a:t>
             </a:r>
           </a:p>
         </p:txBody>
@@ -4867,14 +4822,14 @@
         </p:nvSpPr>
         <p:spPr>
           <a:xfrm>
-            <a:off x="8046720" y="1645920"/>
-            <a:ext cx="3200400" cy="4389120"/>
+            <a:off x="8046720" y="1463040"/>
+            <a:ext cx="3200400" cy="4572000"/>
           </a:xfrm>
           <a:prstGeom prst="roundRect">
             <a:avLst/>
           </a:prstGeom>
           <a:solidFill>
-            <a:srgbClr val="0A1128"/>
+            <a:srgbClr val="1E293B"/>
           </a:solidFill>
           <a:ln w="12700">
             <a:solidFill>
@@ -4903,18 +4858,18 @@
             <a:pPr algn="ctr">
               <a:defRPr sz="1700" b="1">
                 <a:solidFill>
-                  <a:srgbClr val="00FF87"/>
-                </a:solidFill>
-              </a:defRPr>
-            </a:pPr>
-            <a:r>
-              <a:t>🔐 Trustless 2-of-2 Escrow</a:t>
+                  <a:srgbClr val="22C55E"/>
+                </a:solidFill>
+              </a:defRPr>
+            </a:pPr>
+            <a:r>
+              <a:t>Trustless 2-of-2 Escrow</a:t>
             </a:r>
           </a:p>
           <a:p>
             <a:pPr>
               <a:spcBef>
-                <a:spcPts val="1000"/>
+                <a:spcPts val="1600"/>
               </a:spcBef>
               <a:defRPr sz="1300">
                 <a:solidFill>
@@ -4923,13 +4878,13 @@
               </a:defRPr>
             </a:pPr>
             <a:r>
-              <a:t>• Custom CKB Smart Contract script locks funds until handover.</a:t>
+              <a:t>Custom CKB Smart Contract script locks funds until handover.</a:t>
             </a:r>
           </a:p>
           <a:p>
             <a:pPr>
               <a:spcBef>
-                <a:spcPts val="1000"/>
+                <a:spcPts val="1600"/>
               </a:spcBef>
               <a:defRPr sz="1300">
                 <a:solidFill>
@@ -4938,13 +4893,13 @@
               </a:defRPr>
             </a:pPr>
             <a:r>
-              <a:t>• Supports both Local Meetups &amp; Tracked Shipping.</a:t>
+              <a:t>Supports both local meetups and tracked shipping.</a:t>
             </a:r>
           </a:p>
           <a:p>
             <a:pPr>
               <a:spcBef>
-                <a:spcPts val="1000"/>
+                <a:spcPts val="1600"/>
               </a:spcBef>
               <a:defRPr sz="1300">
                 <a:solidFill>
@@ -4953,7 +4908,7 @@
               </a:defRPr>
             </a:pPr>
             <a:r>
-              <a:t>• Dual confirmation releases CKB &amp; transfers DOB automatically.</a:t>
+              <a:t>Dual confirmation triggers CKB release and DOB transfer.</a:t>
             </a:r>
           </a:p>
         </p:txBody>
@@ -4991,7 +4946,7 @@
             <a:avLst/>
           </a:prstGeom>
           <a:solidFill>
-            <a:srgbClr val="0A1128"/>
+            <a:srgbClr val="0F172A"/>
           </a:solidFill>
           <a:ln>
             <a:noFill/>
@@ -5028,7 +4983,7 @@
         <p:spPr>
           <a:xfrm>
             <a:off x="914400" y="548640"/>
-            <a:ext cx="10362895" cy="914400"/>
+            <a:ext cx="10362895" cy="731520"/>
           </a:xfrm>
           <a:prstGeom prst="rect">
             <a:avLst/>
@@ -5044,7 +4999,7 @@
             <a:pPr>
               <a:defRPr sz="3600" b="1">
                 <a:solidFill>
-                  <a:srgbClr val="00FF87"/>
+                  <a:srgbClr val="22C55E"/>
                 </a:solidFill>
               </a:defRPr>
             </a:pPr>
@@ -5062,18 +5017,18 @@
         </p:nvSpPr>
         <p:spPr>
           <a:xfrm>
-            <a:off x="914400" y="1645920"/>
-            <a:ext cx="3200400" cy="4389120"/>
+            <a:off x="914400" y="1463040"/>
+            <a:ext cx="3200400" cy="4572000"/>
           </a:xfrm>
           <a:prstGeom prst="roundRect">
             <a:avLst/>
           </a:prstGeom>
           <a:solidFill>
-            <a:srgbClr val="172043"/>
+            <a:srgbClr val="1E293B"/>
           </a:solidFill>
           <a:ln w="25400">
             <a:solidFill>
-              <a:srgbClr val="00FF87"/>
+              <a:srgbClr val="22C55E"/>
             </a:solidFill>
           </a:ln>
         </p:spPr>
@@ -5098,7 +5053,7 @@
             <a:pPr algn="ctr">
               <a:defRPr sz="1700" b="1">
                 <a:solidFill>
-                  <a:srgbClr val="00FF87"/>
+                  <a:srgbClr val="22C55E"/>
                 </a:solidFill>
               </a:defRPr>
             </a:pPr>
@@ -5118,13 +5073,13 @@
               </a:defRPr>
             </a:pPr>
             <a:r>
-              <a:t>Core Trading &amp; Escrow</a:t>
+              <a:t>Core Escrow &amp; Trading</a:t>
             </a:r>
           </a:p>
           <a:p>
             <a:pPr>
               <a:spcBef>
-                <a:spcPts val="1000"/>
+                <a:spcPts val="1400"/>
               </a:spcBef>
               <a:defRPr sz="1300">
                 <a:solidFill>
@@ -5133,13 +5088,13 @@
               </a:defRPr>
             </a:pPr>
             <a:r>
-              <a:t>• CKB 2-of-2 Escrow Lock scripts</a:t>
+              <a:t>CKB 2-of-2 Escrow Lock scripts</a:t>
             </a:r>
           </a:p>
           <a:p>
             <a:pPr>
               <a:spcBef>
-                <a:spcPts val="1000"/>
+                <a:spcPts val="1400"/>
               </a:spcBef>
               <a:defRPr sz="1300">
                 <a:solidFill>
@@ -5148,13 +5103,13 @@
               </a:defRPr>
             </a:pPr>
             <a:r>
-              <a:t>• Spore DOB Toy Passports &amp; Timeline</a:t>
+              <a:t>Spore DOB Toy Passports &amp; Timeline</a:t>
             </a:r>
           </a:p>
           <a:p>
             <a:pPr>
               <a:spcBef>
-                <a:spcPts val="1000"/>
+                <a:spcPts val="1400"/>
               </a:spcBef>
               <a:defRPr sz="1300">
                 <a:solidFill>
@@ -5163,13 +5118,13 @@
               </a:defRPr>
             </a:pPr>
             <a:r>
-              <a:t>• 📱 QR Meetup Handover</a:t>
+              <a:t>QR Meetup Handover settlement</a:t>
             </a:r>
           </a:p>
           <a:p>
             <a:pPr>
               <a:spcBef>
-                <a:spcPts val="1000"/>
+                <a:spcPts val="1400"/>
               </a:spcBef>
               <a:defRPr sz="1300">
                 <a:solidFill>
@@ -5178,13 +5133,13 @@
               </a:defRPr>
             </a:pPr>
             <a:r>
-              <a:t>• 🛡️ Automated Safety Recall Checker</a:t>
+              <a:t>Automated Safety Recall Screening</a:t>
             </a:r>
           </a:p>
           <a:p>
             <a:pPr>
               <a:spcBef>
-                <a:spcPts val="1000"/>
+                <a:spcPts val="1400"/>
               </a:spcBef>
               <a:defRPr sz="1300">
                 <a:solidFill>
@@ -5193,7 +5148,7 @@
               </a:defRPr>
             </a:pPr>
             <a:r>
-              <a:t>• 💰 3-Price Transparency &amp; JoyID</a:t>
+              <a:t>3-Price Transparency &amp; JoyID</a:t>
             </a:r>
           </a:p>
         </p:txBody>
@@ -5206,14 +5161,14 @@
         </p:nvSpPr>
         <p:spPr>
           <a:xfrm>
-            <a:off x="4480560" y="1645920"/>
-            <a:ext cx="3200400" cy="4389120"/>
+            <a:off x="4480560" y="1463040"/>
+            <a:ext cx="3200400" cy="4572000"/>
           </a:xfrm>
           <a:prstGeom prst="roundRect">
             <a:avLst/>
           </a:prstGeom>
           <a:solidFill>
-            <a:srgbClr val="172043"/>
+            <a:srgbClr val="1E293B"/>
           </a:solidFill>
           <a:ln w="12700">
             <a:solidFill>
@@ -5242,7 +5197,7 @@
             <a:pPr algn="ctr">
               <a:defRPr sz="1700" b="1">
                 <a:solidFill>
-                  <a:srgbClr val="60EFFF"/>
+                  <a:srgbClr val="0EA5E9"/>
                 </a:solidFill>
               </a:defRPr>
             </a:pPr>
@@ -5268,7 +5223,7 @@
           <a:p>
             <a:pPr>
               <a:spcBef>
-                <a:spcPts val="1000"/>
+                <a:spcPts val="1400"/>
               </a:spcBef>
               <a:defRPr sz="1300">
                 <a:solidFill>
@@ -5277,13 +5232,13 @@
               </a:defRPr>
             </a:pPr>
             <a:r>
-              <a:t>• Integrate CKB Fiber L2 payment channels</a:t>
+              <a:t>Integrate CKB Fiber L2 payment channels</a:t>
             </a:r>
           </a:p>
           <a:p>
             <a:pPr>
               <a:spcBef>
-                <a:spcPts val="1000"/>
+                <a:spcPts val="1400"/>
               </a:spcBef>
               <a:defRPr sz="1300">
                 <a:solidFill>
@@ -5292,13 +5247,13 @@
               </a:defRPr>
             </a:pPr>
             <a:r>
-              <a:t>• Ultra-low transaction fees for micro-trades</a:t>
+              <a:t>Ultra-low transaction fees for micro-trades</a:t>
             </a:r>
           </a:p>
           <a:p>
             <a:pPr>
               <a:spcBef>
-                <a:spcPts val="1000"/>
+                <a:spcPts val="1400"/>
               </a:spcBef>
               <a:defRPr sz="1300">
                 <a:solidFill>
@@ -5307,13 +5262,13 @@
               </a:defRPr>
             </a:pPr>
             <a:r>
-              <a:t>• Instant sub-second payment settlement</a:t>
+              <a:t>Sub-second instant payment settlement</a:t>
             </a:r>
           </a:p>
           <a:p>
             <a:pPr>
               <a:spcBef>
-                <a:spcPts val="1000"/>
+                <a:spcPts val="1400"/>
               </a:spcBef>
               <a:defRPr sz="1300">
                 <a:solidFill>
@@ -5322,7 +5277,7 @@
               </a:defRPr>
             </a:pPr>
             <a:r>
-              <a:t>• High-throughput parent trading pipelines</a:t>
+              <a:t>High-throughput parent trading pipelines</a:t>
             </a:r>
           </a:p>
         </p:txBody>
@@ -5335,14 +5290,14 @@
         </p:nvSpPr>
         <p:spPr>
           <a:xfrm>
-            <a:off x="8046720" y="1645920"/>
-            <a:ext cx="3200400" cy="4389120"/>
+            <a:off x="8046720" y="1463040"/>
+            <a:ext cx="3200400" cy="4572000"/>
           </a:xfrm>
           <a:prstGeom prst="roundRect">
             <a:avLst/>
           </a:prstGeom>
           <a:solidFill>
-            <a:srgbClr val="172043"/>
+            <a:srgbClr val="1E293B"/>
           </a:solidFill>
           <a:ln w="12700">
             <a:solidFill>
@@ -5371,7 +5326,7 @@
             <a:pPr algn="ctr">
               <a:defRPr sz="1700" b="1">
                 <a:solidFill>
-                  <a:srgbClr val="60EFFF"/>
+                  <a:srgbClr val="0EA5E9"/>
                 </a:solidFill>
               </a:defRPr>
             </a:pPr>
@@ -5397,7 +5352,7 @@
           <a:p>
             <a:pPr>
               <a:spcBef>
-                <a:spcPts val="1000"/>
+                <a:spcPts val="1400"/>
               </a:spcBef>
               <a:defRPr sz="1300">
                 <a:solidFill>
@@ -5406,13 +5361,13 @@
               </a:defRPr>
             </a:pPr>
             <a:r>
-              <a:t>• Leverage CKB RGB++ / Cross-Chain hubs</a:t>
+              <a:t>Leverage CKB RGB++ cross-chain hubs</a:t>
             </a:r>
           </a:p>
           <a:p>
             <a:pPr>
               <a:spcBef>
-                <a:spcPts val="1000"/>
+                <a:spcPts val="1400"/>
               </a:spcBef>
               <a:defRPr sz="1300">
                 <a:solidFill>
@@ -5421,13 +5376,13 @@
               </a:defRPr>
             </a:pPr>
             <a:r>
-              <a:t>• Settle physical toy trades in native BTC</a:t>
+              <a:t>Settle physical toy trades in native BTC</a:t>
             </a:r>
           </a:p>
           <a:p>
             <a:pPr>
               <a:spcBef>
-                <a:spcPts val="1000"/>
+                <a:spcPts val="1400"/>
               </a:spcBef>
               <a:defRPr sz="1300">
                 <a:solidFill>
@@ -5436,13 +5391,13 @@
               </a:defRPr>
             </a:pPr>
             <a:r>
-              <a:t>• Global liquidity pools for rare collectibles</a:t>
+              <a:t>Global liquidity pools for rare collectibles</a:t>
             </a:r>
           </a:p>
           <a:p>
             <a:pPr>
               <a:spcBef>
-                <a:spcPts val="1000"/>
+                <a:spcPts val="1400"/>
               </a:spcBef>
               <a:defRPr sz="1300">
                 <a:solidFill>
@@ -5451,7 +5406,7 @@
               </a:defRPr>
             </a:pPr>
             <a:r>
-              <a:t>• Cross-border parent trading network</a:t>
+              <a:t>Cross-border parent trading network</a:t>
             </a:r>
           </a:p>
         </p:txBody>

</xml_diff>

<commit_message>
style: align pitch deck with signature ToyTrade dark and neon mint green palette
</commit_message>
<xml_diff>
--- a/toytrade_pitch.pptx
+++ b/toytrade_pitch.pptx
@@ -5,16 +5,16 @@
     <p:sldMasterId xmlns:r="http://schemas.openxmlformats.org/officeDocument/2006/relationships" id="2147483648" r:id="rId1"/>
   </p:sldMasterIdLst>
   <p:notesMasterIdLst>
-    <p:notesMasterId r:id="R5ce076f826ff4cb6"/>
+    <p:notesMasterId r:id="R8647ab6eee8344e3"/>
   </p:notesMasterIdLst>
   <p:sldIdLst>
-    <p:sldId id="256" r:id="Ra1d0083dc87849cf"/>
-    <p:sldId id="257" r:id="R8fed09314bbd426d"/>
-    <p:sldId id="258" r:id="R3132e86a7d704bef"/>
-    <p:sldId id="259" r:id="R7c89a1883c174164"/>
-    <p:sldId id="260" r:id="R833f750edaf24eb7"/>
-    <p:sldId id="261" r:id="R4f91a8f412a44da2"/>
-    <p:sldId id="262" r:id="R2e284e032fbb4b15"/>
+    <p:sldId id="256" r:id="Rad75c695395b45f0"/>
+    <p:sldId id="257" r:id="Rad56c109361740d5"/>
+    <p:sldId id="258" r:id="Rf98f480d8ad2493f"/>
+    <p:sldId id="259" r:id="Rb70595fbfa164bad"/>
+    <p:sldId id="260" r:id="Rd0f7b02584be4ce7"/>
+    <p:sldId id="261" r:id="R6e91af78749e414c"/>
+    <p:sldId id="262" r:id="Rb9af7a9d63804b9c"/>
   </p:sldIdLst>
   <p:sldSz cx="12192000" cy="6858000"/>
   <p:notesSz cx="6858000" cy="9144000"/>
@@ -1116,7 +1116,7 @@
     <p:bg>
       <p:bgPr>
         <a:solidFill xmlns:a="http://schemas.openxmlformats.org/drawingml/2006/main">
-          <a:srgbClr val="1E2761"/>
+          <a:srgbClr val="0A0E12"/>
         </a:solidFill>
       </p:bgPr>
     </p:bg>
@@ -1135,8 +1135,8 @@
         </p:nvSpPr>
         <p:spPr>
           <a:xfrm xmlns:a="http://schemas.openxmlformats.org/drawingml/2006/main">
-            <a:off x="720000" y="1260000"/>
-            <a:ext cx="10753200" cy="1440000"/>
+            <a:off x="720000" y="1152000"/>
+            <a:ext cx="10753200" cy="1368000"/>
           </a:xfrm>
           <a:prstGeom xmlns:a="http://schemas.openxmlformats.org/drawingml/2006/main" prst="rect">
             <a:avLst/>
@@ -1152,8 +1152,8 @@
                 <a:solidFill>
                   <a:srgbClr val="FFFFFF"/>
                 </a:solidFill>
-                <a:latin typeface="Georgia"/>
-                <a:ea typeface="Georgia"/>
+                <a:latin typeface="Inter"/>
+                <a:ea typeface="Inter"/>
               </a:rPr>
               <a:t>ToyTrade</a:t>
             </a:r>
@@ -1168,7 +1168,7 @@
         </p:nvSpPr>
         <p:spPr>
           <a:xfrm xmlns:a="http://schemas.openxmlformats.org/drawingml/2006/main">
-            <a:off x="756000" y="2808000"/>
+            <a:off x="756000" y="2664000"/>
             <a:ext cx="10753200" cy="720000"/>
           </a:xfrm>
           <a:prstGeom xmlns:a="http://schemas.openxmlformats.org/drawingml/2006/main" prst="rect">
@@ -1183,10 +1183,10 @@
             <a:r>
               <a:rPr lang="en-US" sz="2200">
                 <a:solidFill>
-                  <a:srgbClr val="CADCFC"/>
-                </a:solidFill>
-                <a:latin typeface="Calibri"/>
-                <a:ea typeface="Calibri"/>
+                  <a:srgbClr val="60EFFF"/>
+                </a:solidFill>
+                <a:latin typeface="Segoe"/>
+                <a:ea typeface="Segoe"/>
               </a:rPr>
               <a:t>Secure, Provenance-Tracked Kids' Toy Exchange on Nervos CKB</a:t>
             </a:r>
@@ -1201,20 +1201,18 @@
         </p:nvSpPr>
         <p:spPr>
           <a:xfrm xmlns:a="http://schemas.openxmlformats.org/drawingml/2006/main">
-            <a:off x="756000" y="3780000"/>
-            <a:ext cx="5040000" cy="720000"/>
+            <a:off x="756000" y="3672000"/>
+            <a:ext cx="5580000" cy="720000"/>
           </a:xfrm>
           <a:prstGeom xmlns:a="http://schemas.openxmlformats.org/drawingml/2006/main" prst="roundRect">
             <a:avLst/>
           </a:prstGeom>
           <a:solidFill xmlns:a="http://schemas.openxmlformats.org/drawingml/2006/main">
-            <a:srgbClr val="FFFFFF">
-              <a:alpha val="10000"/>
-            </a:srgbClr>
+            <a:srgbClr val="141A20"/>
           </a:solidFill>
           <a:ln xmlns:a="http://schemas.openxmlformats.org/drawingml/2006/main">
             <a:solidFill>
-              <a:srgbClr val="CADCFC"/>
+              <a:srgbClr val="00FF87"/>
             </a:solidFill>
           </a:ln>
         </p:spPr>
@@ -1232,27 +1230,27 @@
         </p:nvSpPr>
         <p:spPr>
           <a:xfrm xmlns:a="http://schemas.openxmlformats.org/drawingml/2006/main">
-            <a:off x="900000" y="3888000"/>
-            <a:ext cx="4680000" cy="540000"/>
-          </a:xfrm>
-          <a:prstGeom xmlns:a="http://schemas.openxmlformats.org/drawingml/2006/main" prst="rect">
-            <a:avLst/>
-          </a:prstGeom>
-          <a:noFill xmlns:a="http://schemas.openxmlformats.org/drawingml/2006/main"/>
-        </p:spPr>
-        <p:txBody>
-          <a:bodyPr xmlns:a="http://schemas.openxmlformats.org/drawingml/2006/main"/>
-          <a:lstStyle xmlns:a="http://schemas.openxmlformats.org/drawingml/2006/main"/>
-          <a:p xmlns:a="http://schemas.openxmlformats.org/drawingml/2006/main">
-            <a:r>
-              <a:rPr lang="en-US" sz="1600" b="1">
+            <a:off x="900000" y="3816000"/>
+            <a:ext cx="5220000" cy="468000"/>
+          </a:xfrm>
+          <a:prstGeom xmlns:a="http://schemas.openxmlformats.org/drawingml/2006/main" prst="rect">
+            <a:avLst/>
+          </a:prstGeom>
+          <a:noFill xmlns:a="http://schemas.openxmlformats.org/drawingml/2006/main"/>
+        </p:spPr>
+        <p:txBody>
+          <a:bodyPr xmlns:a="http://schemas.openxmlformats.org/drawingml/2006/main"/>
+          <a:lstStyle xmlns:a="http://schemas.openxmlformats.org/drawingml/2006/main"/>
+          <a:p xmlns:a="http://schemas.openxmlformats.org/drawingml/2006/main">
+            <a:r>
+              <a:rPr lang="en-US" sz="1500" b="1">
                 <a:solidFill>
                   <a:srgbClr val="00FF87"/>
                 </a:solidFill>
-                <a:latin typeface="Calibri"/>
-                <a:ea typeface="Calibri"/>
-              </a:rPr>
-              <a:t>Protected by CKB Dual-Lock Escrow &amp; Spore DOBs</a:t>
+                <a:latin typeface="Segoe"/>
+                <a:ea typeface="Segoe"/>
+              </a:rPr>
+              <a:t>Protected by CKB Dual-Lock Escrow &amp; Fiber Network</a:t>
             </a:r>
           </a:p>
         </p:txBody>
@@ -1278,24 +1276,24 @@
           <a:lstStyle xmlns:a="http://schemas.openxmlformats.org/drawingml/2006/main"/>
           <a:p xmlns:a="http://schemas.openxmlformats.org/drawingml/2006/main">
             <a:r>
-              <a:rPr lang="en-US" sz="1500">
-                <a:solidFill>
-                  <a:srgbClr val="8899BB"/>
-                </a:solidFill>
-                <a:latin typeface="Calibri"/>
-                <a:ea typeface="Calibri"/>
-              </a:rPr>
-              <a:t>A Blockchain-Powered Alternative to Buying New</a:t>
-            </a:r>
-          </a:p>
-          <a:p xmlns:a="http://schemas.openxmlformats.org/drawingml/2006/main">
-            <a:r>
-              <a:rPr lang="en-US" sz="1500">
-                <a:solidFill>
-                  <a:srgbClr val="8899BB"/>
-                </a:solidFill>
-                <a:latin typeface="Calibri"/>
-                <a:ea typeface="Calibri"/>
+              <a:rPr lang="en-US" sz="1400">
+                <a:solidFill>
+                  <a:srgbClr val="94A3B8"/>
+                </a:solidFill>
+                <a:latin typeface="Segoe"/>
+                <a:ea typeface="Segoe"/>
+              </a:rPr>
+              <a:t>A Blockchain-Powered Sustainable Alternative to Buying New</a:t>
+            </a:r>
+          </a:p>
+          <a:p xmlns:a="http://schemas.openxmlformats.org/drawingml/2006/main">
+            <a:r>
+              <a:rPr lang="en-US" sz="1400">
+                <a:solidFill>
+                  <a:srgbClr val="94A3B8"/>
+                </a:solidFill>
+                <a:latin typeface="Segoe"/>
+                <a:ea typeface="Segoe"/>
               </a:rPr>
               <a:t>August 2026</a:t>
             </a:r>
@@ -1313,7 +1311,7 @@
     <p:bg>
       <p:bgPr>
         <a:solidFill xmlns:a="http://schemas.openxmlformats.org/drawingml/2006/main">
-          <a:srgbClr val="F9F6F0"/>
+          <a:srgbClr val="0A0E12"/>
         </a:solidFill>
       </p:bgPr>
     </p:bg>
@@ -1345,12 +1343,12 @@
           <a:lstStyle xmlns:a="http://schemas.openxmlformats.org/drawingml/2006/main"/>
           <a:p xmlns:a="http://schemas.openxmlformats.org/drawingml/2006/main">
             <a:r>
-              <a:rPr lang="en-US" sz="3800" b="1">
-                <a:solidFill>
-                  <a:srgbClr val="1E2761"/>
-                </a:solidFill>
-                <a:latin typeface="Georgia"/>
-                <a:ea typeface="Georgia"/>
+              <a:rPr lang="en-US" sz="3600" b="1">
+                <a:solidFill>
+                  <a:srgbClr val="FFFFFF"/>
+                </a:solidFill>
+                <a:latin typeface="Inter"/>
+                <a:ea typeface="Inter"/>
               </a:rPr>
               <a:t>Why Parents Need ToyTrade</a:t>
             </a:r>
@@ -1372,11 +1370,11 @@
             <a:avLst/>
           </a:prstGeom>
           <a:solidFill xmlns:a="http://schemas.openxmlformats.org/drawingml/2006/main">
-            <a:srgbClr val="FFFFFF"/>
+            <a:srgbClr val="141A20"/>
           </a:solidFill>
           <a:ln xmlns:a="http://schemas.openxmlformats.org/drawingml/2006/main">
             <a:solidFill>
-              <a:srgbClr val="E0E0E0"/>
+              <a:srgbClr val="332024"/>
             </a:solidFill>
           </a:ln>
         </p:spPr>
@@ -1395,7 +1393,7 @@
         <p:spPr>
           <a:xfrm xmlns:a="http://schemas.openxmlformats.org/drawingml/2006/main">
             <a:off x="900000" y="1620000"/>
-            <a:ext cx="4500000" cy="648000"/>
+            <a:ext cx="4500000" cy="540000"/>
           </a:xfrm>
           <a:prstGeom xmlns:a="http://schemas.openxmlformats.org/drawingml/2006/main" prst="rect">
             <a:avLst/>
@@ -1409,10 +1407,10 @@
             <a:r>
               <a:rPr lang="en-US" sz="2200" b="1">
                 <a:solidFill>
-                  <a:srgbClr val="B85042"/>
-                </a:solidFill>
-                <a:latin typeface="Georgia"/>
-                <a:ea typeface="Georgia"/>
+                  <a:srgbClr val="FF4757"/>
+                </a:solidFill>
+                <a:latin typeface="Inter"/>
+                <a:ea typeface="Inter"/>
               </a:rPr>
               <a:t>The Problem in Second-Hand Trading</a:t>
             </a:r>
@@ -1427,73 +1425,73 @@
         </p:nvSpPr>
         <p:spPr>
           <a:xfrm xmlns:a="http://schemas.openxmlformats.org/drawingml/2006/main">
-            <a:off x="900000" y="2340000"/>
-            <a:ext cx="4500000" cy="3060000"/>
-          </a:xfrm>
-          <a:prstGeom xmlns:a="http://schemas.openxmlformats.org/drawingml/2006/main" prst="rect">
-            <a:avLst/>
-          </a:prstGeom>
-          <a:noFill xmlns:a="http://schemas.openxmlformats.org/drawingml/2006/main"/>
-        </p:spPr>
-        <p:txBody>
-          <a:bodyPr xmlns:a="http://schemas.openxmlformats.org/drawingml/2006/main"/>
-          <a:lstStyle xmlns:a="http://schemas.openxmlformats.org/drawingml/2006/main"/>
-          <a:p xmlns:a="http://schemas.openxmlformats.org/drawingml/2006/main">
-            <a:r>
-              <a:rPr lang="en-US" sz="1700">
-                <a:solidFill>
-                  <a:srgbClr val="333333"/>
-                </a:solidFill>
-                <a:latin typeface="Calibri"/>
-                <a:ea typeface="Calibri"/>
+            <a:off x="900000" y="2268000"/>
+            <a:ext cx="4500000" cy="3168000"/>
+          </a:xfrm>
+          <a:prstGeom xmlns:a="http://schemas.openxmlformats.org/drawingml/2006/main" prst="rect">
+            <a:avLst/>
+          </a:prstGeom>
+          <a:noFill xmlns:a="http://schemas.openxmlformats.org/drawingml/2006/main"/>
+        </p:spPr>
+        <p:txBody>
+          <a:bodyPr xmlns:a="http://schemas.openxmlformats.org/drawingml/2006/main"/>
+          <a:lstStyle xmlns:a="http://schemas.openxmlformats.org/drawingml/2006/main"/>
+          <a:p xmlns:a="http://schemas.openxmlformats.org/drawingml/2006/main">
+            <a:r>
+              <a:rPr lang="en-US" sz="1600">
+                <a:solidFill>
+                  <a:srgbClr val="E2E8F0"/>
+                </a:solidFill>
+                <a:latin typeface="Segoe"/>
+                <a:ea typeface="Segoe"/>
               </a:rPr>
               <a:t>• Rapid Outgrowth: Kids outgrow toys quickly, causing recurring financial waste for families.</a:t>
             </a:r>
           </a:p>
           <a:p xmlns:a="http://schemas.openxmlformats.org/drawingml/2006/main">
             <a:r>
-              <a:rPr lang="en-US" sz="1700">
-                <a:solidFill>
-                  <a:srgbClr val="333333"/>
-                </a:solidFill>
-                <a:latin typeface="Calibri"/>
-                <a:ea typeface="Calibri"/>
+              <a:rPr lang="en-US" sz="1600">
+                <a:solidFill>
+                  <a:srgbClr val="E2E8F0"/>
+                </a:solidFill>
+                <a:latin typeface="Segoe"/>
+                <a:ea typeface="Segoe"/>
               </a:rPr>
               <a:t/>
             </a:r>
           </a:p>
           <a:p xmlns:a="http://schemas.openxmlformats.org/drawingml/2006/main">
             <a:r>
-              <a:rPr lang="en-US" sz="1700">
-                <a:solidFill>
-                  <a:srgbClr val="333333"/>
-                </a:solidFill>
-                <a:latin typeface="Calibri"/>
-                <a:ea typeface="Calibri"/>
+              <a:rPr lang="en-US" sz="1600">
+                <a:solidFill>
+                  <a:srgbClr val="E2E8F0"/>
+                </a:solidFill>
+                <a:latin typeface="Segoe"/>
+                <a:ea typeface="Segoe"/>
               </a:rPr>
               <a:t>• High Counterfeit &amp; Broken Toy Risk: Used marketplaces lack verifiable condition history and safety recall audits.</a:t>
             </a:r>
           </a:p>
           <a:p xmlns:a="http://schemas.openxmlformats.org/drawingml/2006/main">
             <a:r>
-              <a:rPr lang="en-US" sz="1700">
-                <a:solidFill>
-                  <a:srgbClr val="333333"/>
-                </a:solidFill>
-                <a:latin typeface="Calibri"/>
-                <a:ea typeface="Calibri"/>
+              <a:rPr lang="en-US" sz="1600">
+                <a:solidFill>
+                  <a:srgbClr val="E2E8F0"/>
+                </a:solidFill>
+                <a:latin typeface="Segoe"/>
+                <a:ea typeface="Segoe"/>
               </a:rPr>
               <a:t/>
             </a:r>
           </a:p>
           <a:p xmlns:a="http://schemas.openxmlformats.org/drawingml/2006/main">
             <a:r>
-              <a:rPr lang="en-US" sz="1700">
-                <a:solidFill>
-                  <a:srgbClr val="333333"/>
-                </a:solidFill>
-                <a:latin typeface="Calibri"/>
-                <a:ea typeface="Calibri"/>
+              <a:rPr lang="en-US" sz="1600">
+                <a:solidFill>
+                  <a:srgbClr val="E2E8F0"/>
+                </a:solidFill>
+                <a:latin typeface="Segoe"/>
+                <a:ea typeface="Segoe"/>
               </a:rPr>
               <a:t>• Zero Transactional Trust: Meetups and peer payments suffer from fake bank slips, ghosting, and payment disputes.</a:t>
             </a:r>
@@ -1515,10 +1513,12 @@
             <a:avLst/>
           </a:prstGeom>
           <a:solidFill xmlns:a="http://schemas.openxmlformats.org/drawingml/2006/main">
-            <a:srgbClr val="1E2761"/>
+            <a:srgbClr val="141A20"/>
           </a:solidFill>
           <a:ln xmlns:a="http://schemas.openxmlformats.org/drawingml/2006/main">
-            <a:noFill/>
+            <a:solidFill>
+              <a:srgbClr val="00FF87"/>
+            </a:solidFill>
           </a:ln>
         </p:spPr>
         <p:txBody>
@@ -1536,7 +1536,7 @@
         <p:spPr>
           <a:xfrm xmlns:a="http://schemas.openxmlformats.org/drawingml/2006/main">
             <a:off x="6660000" y="1620000"/>
-            <a:ext cx="4500000" cy="648000"/>
+            <a:ext cx="4500000" cy="540000"/>
           </a:xfrm>
           <a:prstGeom xmlns:a="http://schemas.openxmlformats.org/drawingml/2006/main" prst="rect">
             <a:avLst/>
@@ -1550,10 +1550,10 @@
             <a:r>
               <a:rPr lang="en-US" sz="2200" b="1">
                 <a:solidFill>
-                  <a:srgbClr val="CADCFC"/>
-                </a:solidFill>
-                <a:latin typeface="Georgia"/>
-                <a:ea typeface="Georgia"/>
+                  <a:srgbClr val="00FF87"/>
+                </a:solidFill>
+                <a:latin typeface="Inter"/>
+                <a:ea typeface="Inter"/>
               </a:rPr>
               <a:t>The CKB Architecture Solution</a:t>
             </a:r>
@@ -1568,73 +1568,73 @@
         </p:nvSpPr>
         <p:spPr>
           <a:xfrm xmlns:a="http://schemas.openxmlformats.org/drawingml/2006/main">
-            <a:off x="6660000" y="2340000"/>
-            <a:ext cx="4500000" cy="3060000"/>
-          </a:xfrm>
-          <a:prstGeom xmlns:a="http://schemas.openxmlformats.org/drawingml/2006/main" prst="rect">
-            <a:avLst/>
-          </a:prstGeom>
-          <a:noFill xmlns:a="http://schemas.openxmlformats.org/drawingml/2006/main"/>
-        </p:spPr>
-        <p:txBody>
-          <a:bodyPr xmlns:a="http://schemas.openxmlformats.org/drawingml/2006/main"/>
-          <a:lstStyle xmlns:a="http://schemas.openxmlformats.org/drawingml/2006/main"/>
-          <a:p xmlns:a="http://schemas.openxmlformats.org/drawingml/2006/main">
-            <a:r>
-              <a:rPr lang="en-US" sz="1700">
-                <a:solidFill>
-                  <a:srgbClr val="FFFFFF"/>
-                </a:solidFill>
-                <a:latin typeface="Calibri"/>
-                <a:ea typeface="Calibri"/>
+            <a:off x="6660000" y="2268000"/>
+            <a:ext cx="4500000" cy="3168000"/>
+          </a:xfrm>
+          <a:prstGeom xmlns:a="http://schemas.openxmlformats.org/drawingml/2006/main" prst="rect">
+            <a:avLst/>
+          </a:prstGeom>
+          <a:noFill xmlns:a="http://schemas.openxmlformats.org/drawingml/2006/main"/>
+        </p:spPr>
+        <p:txBody>
+          <a:bodyPr xmlns:a="http://schemas.openxmlformats.org/drawingml/2006/main"/>
+          <a:lstStyle xmlns:a="http://schemas.openxmlformats.org/drawingml/2006/main"/>
+          <a:p xmlns:a="http://schemas.openxmlformats.org/drawingml/2006/main">
+            <a:r>
+              <a:rPr lang="en-US" sz="1600">
+                <a:solidFill>
+                  <a:srgbClr val="E2E8F0"/>
+                </a:solidFill>
+                <a:latin typeface="Segoe"/>
+                <a:ea typeface="Segoe"/>
               </a:rPr>
               <a:t>• Dual-Lock Cell Escrow: CKB smart contracts hold settlement funds trustlessly until both parties confirm delivery.</a:t>
             </a:r>
           </a:p>
           <a:p xmlns:a="http://schemas.openxmlformats.org/drawingml/2006/main">
             <a:r>
-              <a:rPr lang="en-US" sz="1700">
-                <a:solidFill>
-                  <a:srgbClr val="FFFFFF"/>
-                </a:solidFill>
-                <a:latin typeface="Calibri"/>
-                <a:ea typeface="Calibri"/>
+              <a:rPr lang="en-US" sz="1600">
+                <a:solidFill>
+                  <a:srgbClr val="E2E8F0"/>
+                </a:solidFill>
+                <a:latin typeface="Segoe"/>
+                <a:ea typeface="Segoe"/>
               </a:rPr>
               <a:t/>
             </a:r>
           </a:p>
           <a:p xmlns:a="http://schemas.openxmlformats.org/drawingml/2006/main">
             <a:r>
-              <a:rPr lang="en-US" sz="1700">
-                <a:solidFill>
-                  <a:srgbClr val="FFFFFF"/>
-                </a:solidFill>
-                <a:latin typeface="Calibri"/>
-                <a:ea typeface="Calibri"/>
+              <a:rPr lang="en-US" sz="1600">
+                <a:solidFill>
+                  <a:srgbClr val="E2E8F0"/>
+                </a:solidFill>
+                <a:latin typeface="Segoe"/>
+                <a:ea typeface="Segoe"/>
               </a:rPr>
               <a:t>• Spore DOB Toy Passport: On-chain digital object tracks toy condition history, owner reviews, and provenance.</a:t>
             </a:r>
           </a:p>
           <a:p xmlns:a="http://schemas.openxmlformats.org/drawingml/2006/main">
             <a:r>
-              <a:rPr lang="en-US" sz="1700">
-                <a:solidFill>
-                  <a:srgbClr val="FFFFFF"/>
-                </a:solidFill>
-                <a:latin typeface="Calibri"/>
-                <a:ea typeface="Calibri"/>
+              <a:rPr lang="en-US" sz="1600">
+                <a:solidFill>
+                  <a:srgbClr val="E2E8F0"/>
+                </a:solidFill>
+                <a:latin typeface="Segoe"/>
+                <a:ea typeface="Segoe"/>
               </a:rPr>
               <a:t/>
             </a:r>
           </a:p>
           <a:p xmlns:a="http://schemas.openxmlformats.org/drawingml/2006/main">
             <a:r>
-              <a:rPr lang="en-US" sz="1700">
-                <a:solidFill>
-                  <a:srgbClr val="FFFFFF"/>
-                </a:solidFill>
-                <a:latin typeface="Calibri"/>
-                <a:ea typeface="Calibri"/>
+              <a:rPr lang="en-US" sz="1600">
+                <a:solidFill>
+                  <a:srgbClr val="E2E8F0"/>
+                </a:solidFill>
+                <a:latin typeface="Segoe"/>
+                <a:ea typeface="Segoe"/>
               </a:rPr>
               <a:t>• JoyID Passkey Biometrics: Parents login and sign with device fingerprint/FaceID without seed phrase friction.</a:t>
             </a:r>
@@ -1652,7 +1652,7 @@
     <p:bg>
       <p:bgPr>
         <a:solidFill xmlns:a="http://schemas.openxmlformats.org/drawingml/2006/main">
-          <a:srgbClr val="F9F6F0"/>
+          <a:srgbClr val="0A0E12"/>
         </a:solidFill>
       </p:bgPr>
     </p:bg>
@@ -1686,10 +1686,10 @@
             <a:r>
               <a:rPr lang="en-US" sz="3400" b="1">
                 <a:solidFill>
-                  <a:srgbClr val="1E2761"/>
-                </a:solidFill>
-                <a:latin typeface="Georgia"/>
-                <a:ea typeface="Georgia"/>
+                  <a:srgbClr val="FFFFFF"/>
+                </a:solidFill>
+                <a:latin typeface="Inter"/>
+                <a:ea typeface="Inter"/>
               </a:rPr>
               <a:t>How CKB Protects Both Buyer and Seller</a:t>
             </a:r>
@@ -1711,11 +1711,11 @@
             <a:avLst/>
           </a:prstGeom>
           <a:solidFill xmlns:a="http://schemas.openxmlformats.org/drawingml/2006/main">
-            <a:srgbClr val="FFFFFF"/>
+            <a:srgbClr val="141A20"/>
           </a:solidFill>
           <a:ln xmlns:a="http://schemas.openxmlformats.org/drawingml/2006/main">
             <a:solidFill>
-              <a:srgbClr val="CADCFC"/>
+              <a:srgbClr val="00FF87"/>
             </a:solidFill>
           </a:ln>
         </p:spPr>
@@ -1740,7 +1740,7 @@
             <a:avLst/>
           </a:prstGeom>
           <a:solidFill xmlns:a="http://schemas.openxmlformats.org/drawingml/2006/main">
-            <a:srgbClr val="1E2761"/>
+            <a:srgbClr val="00FF87"/>
           </a:solidFill>
           <a:ln xmlns:a="http://schemas.openxmlformats.org/drawingml/2006/main">
             <a:noFill/>
@@ -1775,10 +1775,10 @@
             <a:r>
               <a:rPr lang="en-US" sz="1600" b="1">
                 <a:solidFill>
-                  <a:srgbClr val="FFFFFF"/>
-                </a:solidFill>
-                <a:latin typeface="Georgia"/>
-                <a:ea typeface="Georgia"/>
+                  <a:srgbClr val="0A0A0A"/>
+                </a:solidFill>
+                <a:latin typeface="Inter"/>
+                <a:ea typeface="Inter"/>
               </a:rPr>
               <a:t>How CKB Protects the BUYER</a:t>
             </a:r>
@@ -1808,10 +1808,10 @@
             <a:r>
               <a:rPr lang="en-US" sz="1350">
                 <a:solidFill>
-                  <a:srgbClr val="333333"/>
-                </a:solidFill>
-                <a:latin typeface="Calibri"/>
-                <a:ea typeface="Calibri"/>
+                  <a:srgbClr val="E2E8F0"/>
+                </a:solidFill>
+                <a:latin typeface="Segoe"/>
+                <a:ea typeface="Segoe"/>
               </a:rPr>
               <a:t>1. Funds Locked in Smart Contract: Money stays safely in the CKB Escrow Cell until the buyer confirms physical handover.</a:t>
             </a:r>
@@ -1820,10 +1820,10 @@
             <a:r>
               <a:rPr lang="en-US" sz="1350">
                 <a:solidFill>
-                  <a:srgbClr val="333333"/>
-                </a:solidFill>
-                <a:latin typeface="Calibri"/>
-                <a:ea typeface="Calibri"/>
+                  <a:srgbClr val="E2E8F0"/>
+                </a:solidFill>
+                <a:latin typeface="Segoe"/>
+                <a:ea typeface="Segoe"/>
               </a:rPr>
               <a:t/>
             </a:r>
@@ -1832,10 +1832,10 @@
             <a:r>
               <a:rPr lang="en-US" sz="1350">
                 <a:solidFill>
-                  <a:srgbClr val="333333"/>
-                </a:solidFill>
-                <a:latin typeface="Calibri"/>
-                <a:ea typeface="Calibri"/>
+                  <a:srgbClr val="E2E8F0"/>
+                </a:solidFill>
+                <a:latin typeface="Segoe"/>
+                <a:ea typeface="Segoe"/>
               </a:rPr>
               <a:t>2. In-Person Inspection First: Buyer inspects the physical toy at meetup before scanning the QR code to release payment.</a:t>
             </a:r>
@@ -1844,10 +1844,10 @@
             <a:r>
               <a:rPr lang="en-US" sz="1350">
                 <a:solidFill>
-                  <a:srgbClr val="333333"/>
-                </a:solidFill>
-                <a:latin typeface="Calibri"/>
-                <a:ea typeface="Calibri"/>
+                  <a:srgbClr val="E2E8F0"/>
+                </a:solidFill>
+                <a:latin typeface="Segoe"/>
+                <a:ea typeface="Segoe"/>
               </a:rPr>
               <a:t/>
             </a:r>
@@ -1856,10 +1856,10 @@
             <a:r>
               <a:rPr lang="en-US" sz="1350">
                 <a:solidFill>
-                  <a:srgbClr val="333333"/>
-                </a:solidFill>
-                <a:latin typeface="Calibri"/>
-                <a:ea typeface="Calibri"/>
+                  <a:srgbClr val="E2E8F0"/>
+                </a:solidFill>
+                <a:latin typeface="Segoe"/>
+                <a:ea typeface="Segoe"/>
               </a:rPr>
               <a:t>3. 7-Day Auto-Timeout Refund: If the seller ghosts or fails to deliver, buyer independently reclaims 100% of their locked CKB.</a:t>
             </a:r>
@@ -1868,10 +1868,10 @@
             <a:r>
               <a:rPr lang="en-US" sz="1350">
                 <a:solidFill>
-                  <a:srgbClr val="333333"/>
-                </a:solidFill>
-                <a:latin typeface="Calibri"/>
-                <a:ea typeface="Calibri"/>
+                  <a:srgbClr val="E2E8F0"/>
+                </a:solidFill>
+                <a:latin typeface="Segoe"/>
+                <a:ea typeface="Segoe"/>
               </a:rPr>
               <a:t/>
             </a:r>
@@ -1880,10 +1880,10 @@
             <a:r>
               <a:rPr lang="en-US" sz="1350">
                 <a:solidFill>
-                  <a:srgbClr val="333333"/>
-                </a:solidFill>
-                <a:latin typeface="Calibri"/>
-                <a:ea typeface="Calibri"/>
+                  <a:srgbClr val="E2E8F0"/>
+                </a:solidFill>
+                <a:latin typeface="Segoe"/>
+                <a:ea typeface="Segoe"/>
               </a:rPr>
               <a:t>4. Verified Spore DOB Passport: Guarantees authentic ownership history and past parent rating scores.</a:t>
             </a:r>
@@ -1905,11 +1905,11 @@
             <a:avLst/>
           </a:prstGeom>
           <a:solidFill xmlns:a="http://schemas.openxmlformats.org/drawingml/2006/main">
-            <a:srgbClr val="FFFFFF"/>
+            <a:srgbClr val="141A20"/>
           </a:solidFill>
           <a:ln xmlns:a="http://schemas.openxmlformats.org/drawingml/2006/main">
             <a:solidFill>
-              <a:srgbClr val="CADCFC"/>
+              <a:srgbClr val="60EFFF"/>
             </a:solidFill>
           </a:ln>
         </p:spPr>
@@ -1934,7 +1934,7 @@
             <a:avLst/>
           </a:prstGeom>
           <a:solidFill xmlns:a="http://schemas.openxmlformats.org/drawingml/2006/main">
-            <a:srgbClr val="008080"/>
+            <a:srgbClr val="60EFFF"/>
           </a:solidFill>
           <a:ln xmlns:a="http://schemas.openxmlformats.org/drawingml/2006/main">
             <a:noFill/>
@@ -1969,10 +1969,10 @@
             <a:r>
               <a:rPr lang="en-US" sz="1600" b="1">
                 <a:solidFill>
-                  <a:srgbClr val="FFFFFF"/>
-                </a:solidFill>
-                <a:latin typeface="Georgia"/>
-                <a:ea typeface="Georgia"/>
+                  <a:srgbClr val="0A0A0A"/>
+                </a:solidFill>
+                <a:latin typeface="Inter"/>
+                <a:ea typeface="Inter"/>
               </a:rPr>
               <a:t>How CKB Protects the SELLER</a:t>
             </a:r>
@@ -2002,10 +2002,10 @@
             <a:r>
               <a:rPr lang="en-US" sz="1350">
                 <a:solidFill>
-                  <a:srgbClr val="333333"/>
-                </a:solidFill>
-                <a:latin typeface="Calibri"/>
-                <a:ea typeface="Calibri"/>
+                  <a:srgbClr val="E2E8F0"/>
+                </a:solidFill>
+                <a:latin typeface="Segoe"/>
+                <a:ea typeface="Segoe"/>
               </a:rPr>
               <a:t>1. Guaranteed Solvency Before Meetup: Seller only travels after CKB deposit is verified on-chain. Zero fake payment slips.</a:t>
             </a:r>
@@ -2014,10 +2014,10 @@
             <a:r>
               <a:rPr lang="en-US" sz="1350">
                 <a:solidFill>
-                  <a:srgbClr val="333333"/>
-                </a:solidFill>
-                <a:latin typeface="Calibri"/>
-                <a:ea typeface="Calibri"/>
+                  <a:srgbClr val="E2E8F0"/>
+                </a:solidFill>
+                <a:latin typeface="Segoe"/>
+                <a:ea typeface="Segoe"/>
               </a:rPr>
               <a:t/>
             </a:r>
@@ -2026,10 +2026,10 @@
             <a:r>
               <a:rPr lang="en-US" sz="1350">
                 <a:solidFill>
-                  <a:srgbClr val="333333"/>
-                </a:solidFill>
-                <a:latin typeface="Calibri"/>
-                <a:ea typeface="Calibri"/>
+                  <a:srgbClr val="E2E8F0"/>
+                </a:solidFill>
+                <a:latin typeface="Segoe"/>
+                <a:ea typeface="Segoe"/>
               </a:rPr>
               <a:t>2. Zero Chargeback Scams (Non-Repudiation): Once settled via Fiber preimage or dual-sign, payment is final and irreversible.</a:t>
             </a:r>
@@ -2038,10 +2038,10 @@
             <a:r>
               <a:rPr lang="en-US" sz="1350">
                 <a:solidFill>
-                  <a:srgbClr val="333333"/>
-                </a:solidFill>
-                <a:latin typeface="Calibri"/>
-                <a:ea typeface="Calibri"/>
+                  <a:srgbClr val="E2E8F0"/>
+                </a:solidFill>
+                <a:latin typeface="Segoe"/>
+                <a:ea typeface="Segoe"/>
               </a:rPr>
               <a:t/>
             </a:r>
@@ -2050,10 +2050,10 @@
             <a:r>
               <a:rPr lang="en-US" sz="1350">
                 <a:solidFill>
-                  <a:srgbClr val="333333"/>
-                </a:solidFill>
-                <a:latin typeface="Calibri"/>
-                <a:ea typeface="Calibri"/>
+                  <a:srgbClr val="E2E8F0"/>
+                </a:solidFill>
+                <a:latin typeface="Segoe"/>
+                <a:ea typeface="Segoe"/>
               </a:rPr>
               <a:t>3. Instant Handover Settlement: QR scan triggers sub-second release of funds directly to the seller's JoyID wallet.</a:t>
             </a:r>
@@ -2062,10 +2062,10 @@
             <a:r>
               <a:rPr lang="en-US" sz="1350">
                 <a:solidFill>
-                  <a:srgbClr val="333333"/>
-                </a:solidFill>
-                <a:latin typeface="Calibri"/>
-                <a:ea typeface="Calibri"/>
+                  <a:srgbClr val="E2E8F0"/>
+                </a:solidFill>
+                <a:latin typeface="Segoe"/>
+                <a:ea typeface="Segoe"/>
               </a:rPr>
               <a:t/>
             </a:r>
@@ -2074,10 +2074,10 @@
             <a:r>
               <a:rPr lang="en-US" sz="1350">
                 <a:solidFill>
-                  <a:srgbClr val="333333"/>
-                </a:solidFill>
-                <a:latin typeface="Calibri"/>
-                <a:ea typeface="Calibri"/>
+                  <a:srgbClr val="E2E8F0"/>
+                </a:solidFill>
+                <a:latin typeface="Segoe"/>
+                <a:ea typeface="Segoe"/>
               </a:rPr>
               <a:t>4. Immutable Seller Reputation: Completed trades record permanent on-chain ratings that protect honest sellers.</a:t>
             </a:r>
@@ -2095,7 +2095,7 @@
     <p:bg>
       <p:bgPr>
         <a:solidFill xmlns:a="http://schemas.openxmlformats.org/drawingml/2006/main">
-          <a:srgbClr val="F9F6F0"/>
+          <a:srgbClr val="0A0E12"/>
         </a:solidFill>
       </p:bgPr>
     </p:bg>
@@ -2127,12 +2127,12 @@
           <a:lstStyle xmlns:a="http://schemas.openxmlformats.org/drawingml/2006/main"/>
           <a:p xmlns:a="http://schemas.openxmlformats.org/drawingml/2006/main">
             <a:r>
-              <a:rPr lang="en-US" sz="3800" b="1">
-                <a:solidFill>
-                  <a:srgbClr val="1E2761"/>
-                </a:solidFill>
-                <a:latin typeface="Georgia"/>
-                <a:ea typeface="Georgia"/>
+              <a:rPr lang="en-US" sz="3600" b="1">
+                <a:solidFill>
+                  <a:srgbClr val="FFFFFF"/>
+                </a:solidFill>
+                <a:latin typeface="Inter"/>
+                <a:ea typeface="Inter"/>
               </a:rPr>
               <a:t>Three-Price Market Integrity</a:t>
             </a:r>
@@ -2154,11 +2154,11 @@
             <a:avLst/>
           </a:prstGeom>
           <a:solidFill xmlns:a="http://schemas.openxmlformats.org/drawingml/2006/main">
-            <a:srgbClr val="FFFFFF"/>
+            <a:srgbClr val="141A20"/>
           </a:solidFill>
           <a:ln xmlns:a="http://schemas.openxmlformats.org/drawingml/2006/main">
             <a:solidFill>
-              <a:srgbClr val="E0E0E0"/>
+              <a:srgbClr val="222D37"/>
             </a:solidFill>
           </a:ln>
         </p:spPr>
@@ -2191,10 +2191,10 @@
             <a:r>
               <a:rPr lang="en-US" sz="2200" b="1">
                 <a:solidFill>
-                  <a:srgbClr val="1E2761"/>
-                </a:solidFill>
-                <a:latin typeface="Georgia"/>
-                <a:ea typeface="Georgia"/>
+                  <a:srgbClr val="60EFFF"/>
+                </a:solidFill>
+                <a:latin typeface="Inter"/>
+                <a:ea typeface="Inter"/>
               </a:rPr>
               <a:t>① Seller's Price</a:t>
             </a:r>
@@ -2222,36 +2222,36 @@
           <a:lstStyle xmlns:a="http://schemas.openxmlformats.org/drawingml/2006/main"/>
           <a:p xmlns:a="http://schemas.openxmlformats.org/drawingml/2006/main">
             <a:r>
-              <a:rPr lang="en-US" sz="1700">
-                <a:solidFill>
-                  <a:srgbClr val="333333"/>
-                </a:solidFill>
-                <a:latin typeface="Calibri"/>
-                <a:ea typeface="Calibri"/>
+              <a:rPr lang="en-US" sz="1600">
+                <a:solidFill>
+                  <a:srgbClr val="E2E8F0"/>
+                </a:solidFill>
+                <a:latin typeface="Segoe"/>
+                <a:ea typeface="Segoe"/>
               </a:rPr>
               <a:t>Set directly by parents in their local currency (£ GBP / ₫ VND).</a:t>
             </a:r>
           </a:p>
           <a:p xmlns:a="http://schemas.openxmlformats.org/drawingml/2006/main">
             <a:r>
-              <a:rPr lang="en-US" sz="1700">
-                <a:solidFill>
-                  <a:srgbClr val="333333"/>
-                </a:solidFill>
-                <a:latin typeface="Calibri"/>
-                <a:ea typeface="Calibri"/>
+              <a:rPr lang="en-US" sz="1600">
+                <a:solidFill>
+                  <a:srgbClr val="E2E8F0"/>
+                </a:solidFill>
+                <a:latin typeface="Segoe"/>
+                <a:ea typeface="Segoe"/>
               </a:rPr>
               <a:t/>
             </a:r>
           </a:p>
           <a:p xmlns:a="http://schemas.openxmlformats.org/drawingml/2006/main">
             <a:r>
-              <a:rPr lang="en-US" sz="1700">
-                <a:solidFill>
-                  <a:srgbClr val="333333"/>
-                </a:solidFill>
-                <a:latin typeface="Calibri"/>
-                <a:ea typeface="Calibri"/>
+              <a:rPr lang="en-US" sz="1600">
+                <a:solidFill>
+                  <a:srgbClr val="E2E8F0"/>
+                </a:solidFill>
+                <a:latin typeface="Segoe"/>
+                <a:ea typeface="Segoe"/>
               </a:rPr>
               <a:t>Maintains a familiar, friendly fiat shopping experience for non-crypto parents.</a:t>
             </a:r>
@@ -2273,11 +2273,11 @@
             <a:avLst/>
           </a:prstGeom>
           <a:solidFill xmlns:a="http://schemas.openxmlformats.org/drawingml/2006/main">
-            <a:srgbClr val="FFFFFF"/>
+            <a:srgbClr val="141A20"/>
           </a:solidFill>
           <a:ln xmlns:a="http://schemas.openxmlformats.org/drawingml/2006/main">
             <a:solidFill>
-              <a:srgbClr val="E0E0E0"/>
+              <a:srgbClr val="222D37"/>
             </a:solidFill>
           </a:ln>
         </p:spPr>
@@ -2310,10 +2310,10 @@
             <a:r>
               <a:rPr lang="en-US" sz="2200" b="1">
                 <a:solidFill>
-                  <a:srgbClr val="B85042"/>
-                </a:solidFill>
-                <a:latin typeface="Georgia"/>
-                <a:ea typeface="Georgia"/>
+                  <a:srgbClr val="FFC107"/>
+                </a:solidFill>
+                <a:latin typeface="Inter"/>
+                <a:ea typeface="Inter"/>
               </a:rPr>
               <a:t>② Market Reference</a:t>
             </a:r>
@@ -2341,36 +2341,36 @@
           <a:lstStyle xmlns:a="http://schemas.openxmlformats.org/drawingml/2006/main"/>
           <a:p xmlns:a="http://schemas.openxmlformats.org/drawingml/2006/main">
             <a:r>
-              <a:rPr lang="en-US" sz="1700">
-                <a:solidFill>
-                  <a:srgbClr val="333333"/>
-                </a:solidFill>
-                <a:latin typeface="Calibri"/>
-                <a:ea typeface="Calibri"/>
+              <a:rPr lang="en-US" sz="1600">
+                <a:solidFill>
+                  <a:srgbClr val="E2E8F0"/>
+                </a:solidFill>
+                <a:latin typeface="Segoe"/>
+                <a:ea typeface="Segoe"/>
               </a:rPr>
               <a:t>Retrieved automatically via Google Lens visual shopping matches.</a:t>
             </a:r>
           </a:p>
           <a:p xmlns:a="http://schemas.openxmlformats.org/drawingml/2006/main">
             <a:r>
-              <a:rPr lang="en-US" sz="1700">
-                <a:solidFill>
-                  <a:srgbClr val="333333"/>
-                </a:solidFill>
-                <a:latin typeface="Calibri"/>
-                <a:ea typeface="Calibri"/>
+              <a:rPr lang="en-US" sz="1600">
+                <a:solidFill>
+                  <a:srgbClr val="E2E8F0"/>
+                </a:solidFill>
+                <a:latin typeface="Segoe"/>
+                <a:ea typeface="Segoe"/>
               </a:rPr>
               <a:t/>
             </a:r>
           </a:p>
           <a:p xmlns:a="http://schemas.openxmlformats.org/drawingml/2006/main">
             <a:r>
-              <a:rPr lang="en-US" sz="1700">
-                <a:solidFill>
-                  <a:srgbClr val="333333"/>
-                </a:solidFill>
-                <a:latin typeface="Calibri"/>
-                <a:ea typeface="Calibri"/>
+              <a:rPr lang="en-US" sz="1600">
+                <a:solidFill>
+                  <a:srgbClr val="E2E8F0"/>
+                </a:solidFill>
+                <a:latin typeface="Segoe"/>
+                <a:ea typeface="Segoe"/>
               </a:rPr>
               <a:t>Protects buyers against overpriced listings and helps sellers price fairly.</a:t>
             </a:r>
@@ -2392,10 +2392,12 @@
             <a:avLst/>
           </a:prstGeom>
           <a:solidFill xmlns:a="http://schemas.openxmlformats.org/drawingml/2006/main">
-            <a:srgbClr val="1E2761"/>
+            <a:srgbClr val="141A20"/>
           </a:solidFill>
           <a:ln xmlns:a="http://schemas.openxmlformats.org/drawingml/2006/main">
-            <a:noFill/>
+            <a:solidFill>
+              <a:srgbClr val="00FF87"/>
+            </a:solidFill>
           </a:ln>
         </p:spPr>
         <p:txBody>
@@ -2427,10 +2429,10 @@
             <a:r>
               <a:rPr lang="en-US" sz="2200" b="1">
                 <a:solidFill>
-                  <a:srgbClr val="CADCFC"/>
-                </a:solidFill>
-                <a:latin typeface="Georgia"/>
-                <a:ea typeface="Georgia"/>
+                  <a:srgbClr val="00FF87"/>
+                </a:solidFill>
+                <a:latin typeface="Inter"/>
+                <a:ea typeface="Inter"/>
               </a:rPr>
               <a:t>③ CKB Equivalent</a:t>
             </a:r>
@@ -2458,36 +2460,36 @@
           <a:lstStyle xmlns:a="http://schemas.openxmlformats.org/drawingml/2006/main"/>
           <a:p xmlns:a="http://schemas.openxmlformats.org/drawingml/2006/main">
             <a:r>
-              <a:rPr lang="en-US" sz="1700">
-                <a:solidFill>
-                  <a:srgbClr val="FFFFFF"/>
-                </a:solidFill>
-                <a:latin typeface="Calibri"/>
-                <a:ea typeface="Calibri"/>
+              <a:rPr lang="en-US" sz="1600">
+                <a:solidFill>
+                  <a:srgbClr val="E2E8F0"/>
+                </a:solidFill>
+                <a:latin typeface="Segoe"/>
+                <a:ea typeface="Segoe"/>
               </a:rPr>
               <a:t>Converted in real-time from live CoinGecko price feeds.</a:t>
             </a:r>
           </a:p>
           <a:p xmlns:a="http://schemas.openxmlformats.org/drawingml/2006/main">
             <a:r>
-              <a:rPr lang="en-US" sz="1700">
-                <a:solidFill>
-                  <a:srgbClr val="FFFFFF"/>
-                </a:solidFill>
-                <a:latin typeface="Calibri"/>
-                <a:ea typeface="Calibri"/>
+              <a:rPr lang="en-US" sz="1600">
+                <a:solidFill>
+                  <a:srgbClr val="E2E8F0"/>
+                </a:solidFill>
+                <a:latin typeface="Segoe"/>
+                <a:ea typeface="Segoe"/>
               </a:rPr>
               <a:t/>
             </a:r>
           </a:p>
           <a:p xmlns:a="http://schemas.openxmlformats.org/drawingml/2006/main">
             <a:r>
-              <a:rPr lang="en-US" sz="1700">
-                <a:solidFill>
-                  <a:srgbClr val="FFFFFF"/>
-                </a:solidFill>
-                <a:latin typeface="Calibri"/>
-                <a:ea typeface="Calibri"/>
+              <a:rPr lang="en-US" sz="1600">
+                <a:solidFill>
+                  <a:srgbClr val="E2E8F0"/>
+                </a:solidFill>
+                <a:latin typeface="Segoe"/>
+                <a:ea typeface="Segoe"/>
               </a:rPr>
               <a:t>Locked at trade initiation for on-chain escrow or Fiber invoice settlement.</a:t>
             </a:r>
@@ -2505,7 +2507,7 @@
     <p:bg>
       <p:bgPr>
         <a:solidFill xmlns:a="http://schemas.openxmlformats.org/drawingml/2006/main">
-          <a:srgbClr val="F9F6F0"/>
+          <a:srgbClr val="0A0E12"/>
         </a:solidFill>
       </p:bgPr>
     </p:bg>
@@ -2537,12 +2539,12 @@
           <a:lstStyle xmlns:a="http://schemas.openxmlformats.org/drawingml/2006/main"/>
           <a:p xmlns:a="http://schemas.openxmlformats.org/drawingml/2006/main">
             <a:r>
-              <a:rPr lang="en-US" sz="3800" b="1">
-                <a:solidFill>
-                  <a:srgbClr val="1E2761"/>
-                </a:solidFill>
-                <a:latin typeface="Georgia"/>
-                <a:ea typeface="Georgia"/>
+              <a:rPr lang="en-US" sz="3600" b="1">
+                <a:solidFill>
+                  <a:srgbClr val="FFFFFF"/>
+                </a:solidFill>
+                <a:latin typeface="Inter"/>
+                <a:ea typeface="Inter"/>
               </a:rPr>
               <a:t>End-to-End Trade Settlement Lifecycle</a:t>
             </a:r>
@@ -2564,7 +2566,7 @@
             <a:avLst/>
           </a:prstGeom>
           <a:solidFill xmlns:a="http://schemas.openxmlformats.org/drawingml/2006/main">
-            <a:srgbClr val="1E2761"/>
+            <a:srgbClr val="00FF87"/>
           </a:solidFill>
         </p:spPr>
         <p:txBody>
@@ -2572,12 +2574,12 @@
           <a:lstStyle xmlns:a="http://schemas.openxmlformats.org/drawingml/2006/main"/>
           <a:p xmlns:a="http://schemas.openxmlformats.org/drawingml/2006/main">
             <a:r>
-              <a:rPr lang="en-US" sz="1800" b="1">
-                <a:solidFill>
-                  <a:srgbClr val="FFFFFF"/>
-                </a:solidFill>
-                <a:latin typeface="Georgia"/>
-                <a:ea typeface="Georgia"/>
+              <a:rPr lang="en-US" sz="1600" b="1">
+                <a:solidFill>
+                  <a:srgbClr val="0A0A0A"/>
+                </a:solidFill>
+                <a:latin typeface="Inter"/>
+                <a:ea typeface="Inter"/>
               </a:rPr>
               <a:t>1. Lock Escrow</a:t>
             </a:r>
@@ -2605,12 +2607,12 @@
           <a:lstStyle xmlns:a="http://schemas.openxmlformats.org/drawingml/2006/main"/>
           <a:p xmlns:a="http://schemas.openxmlformats.org/drawingml/2006/main">
             <a:r>
-              <a:rPr lang="en-US" sz="1700">
-                <a:solidFill>
-                  <a:srgbClr val="333333"/>
-                </a:solidFill>
-                <a:latin typeface="Calibri"/>
-                <a:ea typeface="Calibri"/>
+              <a:rPr lang="en-US" sz="1600">
+                <a:solidFill>
+                  <a:srgbClr val="E2E8F0"/>
+                </a:solidFill>
+                <a:latin typeface="Segoe"/>
+                <a:ea typeface="Segoe"/>
               </a:rPr>
               <a:t>Buyer funds the trade; CKB is locked inside the 2-of-2 Escrow Lock Cell on Layer 1.</a:t>
             </a:r>
@@ -2632,7 +2634,7 @@
             <a:avLst/>
           </a:prstGeom>
           <a:solidFill xmlns:a="http://schemas.openxmlformats.org/drawingml/2006/main">
-            <a:srgbClr val="1E2761"/>
+            <a:srgbClr val="60EFFF"/>
           </a:solidFill>
         </p:spPr>
         <p:txBody>
@@ -2640,12 +2642,12 @@
           <a:lstStyle xmlns:a="http://schemas.openxmlformats.org/drawingml/2006/main"/>
           <a:p xmlns:a="http://schemas.openxmlformats.org/drawingml/2006/main">
             <a:r>
-              <a:rPr lang="en-US" sz="1800" b="1">
-                <a:solidFill>
-                  <a:srgbClr val="FFFFFF"/>
-                </a:solidFill>
-                <a:latin typeface="Georgia"/>
-                <a:ea typeface="Georgia"/>
+              <a:rPr lang="en-US" sz="1600" b="1">
+                <a:solidFill>
+                  <a:srgbClr val="0A0A0A"/>
+                </a:solidFill>
+                <a:latin typeface="Inter"/>
+                <a:ea typeface="Inter"/>
               </a:rPr>
               <a:t>2. Meetup / Ship</a:t>
             </a:r>
@@ -2673,12 +2675,12 @@
           <a:lstStyle xmlns:a="http://schemas.openxmlformats.org/drawingml/2006/main"/>
           <a:p xmlns:a="http://schemas.openxmlformats.org/drawingml/2006/main">
             <a:r>
-              <a:rPr lang="en-US" sz="1700">
-                <a:solidFill>
-                  <a:srgbClr val="333333"/>
-                </a:solidFill>
-                <a:latin typeface="Calibri"/>
-                <a:ea typeface="Calibri"/>
+              <a:rPr lang="en-US" sz="1600">
+                <a:solidFill>
+                  <a:srgbClr val="E2E8F0"/>
+                </a:solidFill>
+                <a:latin typeface="Segoe"/>
+                <a:ea typeface="Segoe"/>
               </a:rPr>
               <a:t>Seller hands over physical toy at local meetup or dispatches tracked shipping package.</a:t>
             </a:r>
@@ -2700,7 +2702,7 @@
             <a:avLst/>
           </a:prstGeom>
           <a:solidFill xmlns:a="http://schemas.openxmlformats.org/drawingml/2006/main">
-            <a:srgbClr val="1E2761"/>
+            <a:srgbClr val="00FF87"/>
           </a:solidFill>
         </p:spPr>
         <p:txBody>
@@ -2708,12 +2710,12 @@
           <a:lstStyle xmlns:a="http://schemas.openxmlformats.org/drawingml/2006/main"/>
           <a:p xmlns:a="http://schemas.openxmlformats.org/drawingml/2006/main">
             <a:r>
-              <a:rPr lang="en-US" sz="1800" b="1">
-                <a:solidFill>
-                  <a:srgbClr val="FFFFFF"/>
-                </a:solidFill>
-                <a:latin typeface="Georgia"/>
-                <a:ea typeface="Georgia"/>
+              <a:rPr lang="en-US" sz="1600" b="1">
+                <a:solidFill>
+                  <a:srgbClr val="0A0A0A"/>
+                </a:solidFill>
+                <a:latin typeface="Inter"/>
+                <a:ea typeface="Inter"/>
               </a:rPr>
               <a:t>3. Dual Release</a:t>
             </a:r>
@@ -2741,12 +2743,12 @@
           <a:lstStyle xmlns:a="http://schemas.openxmlformats.org/drawingml/2006/main"/>
           <a:p xmlns:a="http://schemas.openxmlformats.org/drawingml/2006/main">
             <a:r>
-              <a:rPr lang="en-US" sz="1700">
-                <a:solidFill>
-                  <a:srgbClr val="333333"/>
-                </a:solidFill>
-                <a:latin typeface="Calibri"/>
-                <a:ea typeface="Calibri"/>
+              <a:rPr lang="en-US" sz="1600">
+                <a:solidFill>
+                  <a:srgbClr val="E2E8F0"/>
+                </a:solidFill>
+                <a:latin typeface="Segoe"/>
+                <a:ea typeface="Segoe"/>
               </a:rPr>
               <a:t>Buyer scans seller's QR code (or confirms online); CKB releases to seller &amp; Spore DOB transfers to buyer.</a:t>
             </a:r>
@@ -2768,7 +2770,7 @@
             <a:avLst/>
           </a:prstGeom>
           <a:solidFill xmlns:a="http://schemas.openxmlformats.org/drawingml/2006/main">
-            <a:srgbClr val="B85042"/>
+            <a:srgbClr val="FF4757"/>
           </a:solidFill>
         </p:spPr>
         <p:txBody>
@@ -2776,12 +2778,12 @@
           <a:lstStyle xmlns:a="http://schemas.openxmlformats.org/drawingml/2006/main"/>
           <a:p xmlns:a="http://schemas.openxmlformats.org/drawingml/2006/main">
             <a:r>
-              <a:rPr lang="en-US" sz="1800" b="1">
+              <a:rPr lang="en-US" sz="1600" b="1">
                 <a:solidFill>
                   <a:srgbClr val="FFFFFF"/>
                 </a:solidFill>
-                <a:latin typeface="Georgia"/>
-                <a:ea typeface="Georgia"/>
+                <a:latin typeface="Inter"/>
+                <a:ea typeface="Inter"/>
               </a:rPr>
               <a:t>Safeguard</a:t>
             </a:r>
@@ -2809,12 +2811,12 @@
           <a:lstStyle xmlns:a="http://schemas.openxmlformats.org/drawingml/2006/main"/>
           <a:p xmlns:a="http://schemas.openxmlformats.org/drawingml/2006/main">
             <a:r>
-              <a:rPr lang="en-US" sz="1700">
-                <a:solidFill>
-                  <a:srgbClr val="333333"/>
-                </a:solidFill>
-                <a:latin typeface="Calibri"/>
-                <a:ea typeface="Calibri"/>
+              <a:rPr lang="en-US" sz="1600">
+                <a:solidFill>
+                  <a:srgbClr val="E2E8F0"/>
+                </a:solidFill>
+                <a:latin typeface="Segoe"/>
+                <a:ea typeface="Segoe"/>
               </a:rPr>
               <a:t>7-day timelock allows buyer to reclaim 100% of locked funds if seller fails to deliver.</a:t>
             </a:r>
@@ -2832,7 +2834,7 @@
     <p:bg>
       <p:bgPr>
         <a:solidFill xmlns:a="http://schemas.openxmlformats.org/drawingml/2006/main">
-          <a:srgbClr val="F9F6F0"/>
+          <a:srgbClr val="0A0E12"/>
         </a:solidFill>
       </p:bgPr>
     </p:bg>
@@ -2864,12 +2866,12 @@
           <a:lstStyle xmlns:a="http://schemas.openxmlformats.org/drawingml/2006/main"/>
           <a:p xmlns:a="http://schemas.openxmlformats.org/drawingml/2006/main">
             <a:r>
-              <a:rPr lang="en-US" sz="3600" b="1">
-                <a:solidFill>
-                  <a:srgbClr val="1E2761"/>
-                </a:solidFill>
-                <a:latin typeface="Georgia"/>
-                <a:ea typeface="Georgia"/>
+              <a:rPr lang="en-US" sz="3400" b="1">
+                <a:solidFill>
+                  <a:srgbClr val="FFFFFF"/>
+                </a:solidFill>
+                <a:latin typeface="Inter"/>
+                <a:ea typeface="Inter"/>
               </a:rPr>
               <a:t>Security Architecture &amp; Cryptographic Auth</a:t>
             </a:r>
@@ -2891,11 +2893,11 @@
             <a:avLst/>
           </a:prstGeom>
           <a:solidFill xmlns:a="http://schemas.openxmlformats.org/drawingml/2006/main">
-            <a:srgbClr val="FFFFFF"/>
+            <a:srgbClr val="141A20"/>
           </a:solidFill>
           <a:ln xmlns:a="http://schemas.openxmlformats.org/drawingml/2006/main">
             <a:solidFill>
-              <a:srgbClr val="E0E0E0"/>
+              <a:srgbClr val="00FF87"/>
             </a:solidFill>
           </a:ln>
         </p:spPr>
@@ -2928,10 +2930,10 @@
             <a:r>
               <a:rPr lang="en-US" sz="2000" b="1">
                 <a:solidFill>
-                  <a:srgbClr val="1E2761"/>
-                </a:solidFill>
-                <a:latin typeface="Georgia"/>
-                <a:ea typeface="Georgia"/>
+                  <a:srgbClr val="00FF87"/>
+                </a:solidFill>
+                <a:latin typeface="Inter"/>
+                <a:ea typeface="Inter"/>
               </a:rPr>
               <a:t>1. JoyID &amp; CCC Auth</a:t>
             </a:r>
@@ -2959,60 +2961,60 @@
           <a:lstStyle xmlns:a="http://schemas.openxmlformats.org/drawingml/2006/main"/>
           <a:p xmlns:a="http://schemas.openxmlformats.org/drawingml/2006/main">
             <a:r>
-              <a:rPr lang="en-US" sz="1600">
-                <a:solidFill>
-                  <a:srgbClr val="333333"/>
-                </a:solidFill>
-                <a:latin typeface="Calibri"/>
-                <a:ea typeface="Calibri"/>
+              <a:rPr lang="en-US" sz="1500">
+                <a:solidFill>
+                  <a:srgbClr val="E2E8F0"/>
+                </a:solidFill>
+                <a:latin typeface="Segoe"/>
+                <a:ea typeface="Segoe"/>
               </a:rPr>
               <a:t>• Uses CKB Common Chain Connector (CCC) SDK.</a:t>
             </a:r>
           </a:p>
           <a:p xmlns:a="http://schemas.openxmlformats.org/drawingml/2006/main">
             <a:r>
-              <a:rPr lang="en-US" sz="1600">
-                <a:solidFill>
-                  <a:srgbClr val="333333"/>
-                </a:solidFill>
-                <a:latin typeface="Calibri"/>
-                <a:ea typeface="Calibri"/>
+              <a:rPr lang="en-US" sz="1500">
+                <a:solidFill>
+                  <a:srgbClr val="E2E8F0"/>
+                </a:solidFill>
+                <a:latin typeface="Segoe"/>
+                <a:ea typeface="Segoe"/>
               </a:rPr>
               <a:t/>
             </a:r>
           </a:p>
           <a:p xmlns:a="http://schemas.openxmlformats.org/drawingml/2006/main">
             <a:r>
-              <a:rPr lang="en-US" sz="1600">
-                <a:solidFill>
-                  <a:srgbClr val="333333"/>
-                </a:solidFill>
-                <a:latin typeface="Calibri"/>
-                <a:ea typeface="Calibri"/>
+              <a:rPr lang="en-US" sz="1500">
+                <a:solidFill>
+                  <a:srgbClr val="E2E8F0"/>
+                </a:solidFill>
+                <a:latin typeface="Segoe"/>
+                <a:ea typeface="Segoe"/>
               </a:rPr>
               <a:t>• Verifies WebAuthn passkey signatures on backend before accepting listings or chat messages.</a:t>
             </a:r>
           </a:p>
           <a:p xmlns:a="http://schemas.openxmlformats.org/drawingml/2006/main">
             <a:r>
-              <a:rPr lang="en-US" sz="1600">
-                <a:solidFill>
-                  <a:srgbClr val="333333"/>
-                </a:solidFill>
-                <a:latin typeface="Calibri"/>
-                <a:ea typeface="Calibri"/>
+              <a:rPr lang="en-US" sz="1500">
+                <a:solidFill>
+                  <a:srgbClr val="E2E8F0"/>
+                </a:solidFill>
+                <a:latin typeface="Segoe"/>
+                <a:ea typeface="Segoe"/>
               </a:rPr>
               <a:t/>
             </a:r>
           </a:p>
           <a:p xmlns:a="http://schemas.openxmlformats.org/drawingml/2006/main">
             <a:r>
-              <a:rPr lang="en-US" sz="1600">
-                <a:solidFill>
-                  <a:srgbClr val="333333"/>
-                </a:solidFill>
-                <a:latin typeface="Calibri"/>
-                <a:ea typeface="Calibri"/>
+              <a:rPr lang="en-US" sz="1500">
+                <a:solidFill>
+                  <a:srgbClr val="E2E8F0"/>
+                </a:solidFill>
+                <a:latin typeface="Segoe"/>
+                <a:ea typeface="Segoe"/>
               </a:rPr>
               <a:t>• Zero identity spoofing or unauthorized trade modifications.</a:t>
             </a:r>
@@ -3034,11 +3036,11 @@
             <a:avLst/>
           </a:prstGeom>
           <a:solidFill xmlns:a="http://schemas.openxmlformats.org/drawingml/2006/main">
-            <a:srgbClr val="FFFFFF"/>
+            <a:srgbClr val="141A20"/>
           </a:solidFill>
           <a:ln xmlns:a="http://schemas.openxmlformats.org/drawingml/2006/main">
             <a:solidFill>
-              <a:srgbClr val="E0E0E0"/>
+              <a:srgbClr val="60EFFF"/>
             </a:solidFill>
           </a:ln>
         </p:spPr>
@@ -3071,10 +3073,10 @@
             <a:r>
               <a:rPr lang="en-US" sz="2000" b="1">
                 <a:solidFill>
-                  <a:srgbClr val="1E2761"/>
-                </a:solidFill>
-                <a:latin typeface="Georgia"/>
-                <a:ea typeface="Georgia"/>
+                  <a:srgbClr val="60EFFF"/>
+                </a:solidFill>
+                <a:latin typeface="Inter"/>
+                <a:ea typeface="Inter"/>
               </a:rPr>
               <a:t>2. Smart Escrow</a:t>
             </a:r>
@@ -3102,60 +3104,60 @@
           <a:lstStyle xmlns:a="http://schemas.openxmlformats.org/drawingml/2006/main"/>
           <a:p xmlns:a="http://schemas.openxmlformats.org/drawingml/2006/main">
             <a:r>
-              <a:rPr lang="en-US" sz="1600">
-                <a:solidFill>
-                  <a:srgbClr val="333333"/>
-                </a:solidFill>
-                <a:latin typeface="Calibri"/>
-                <a:ea typeface="Calibri"/>
+              <a:rPr lang="en-US" sz="1500">
+                <a:solidFill>
+                  <a:srgbClr val="E2E8F0"/>
+                </a:solidFill>
+                <a:latin typeface="Segoe"/>
+                <a:ea typeface="Segoe"/>
               </a:rPr>
               <a:t>• Custom Rust CKB lock script.</a:t>
             </a:r>
           </a:p>
           <a:p xmlns:a="http://schemas.openxmlformats.org/drawingml/2006/main">
             <a:r>
-              <a:rPr lang="en-US" sz="1600">
-                <a:solidFill>
-                  <a:srgbClr val="333333"/>
-                </a:solidFill>
-                <a:latin typeface="Calibri"/>
-                <a:ea typeface="Calibri"/>
+              <a:rPr lang="en-US" sz="1500">
+                <a:solidFill>
+                  <a:srgbClr val="E2E8F0"/>
+                </a:solidFill>
+                <a:latin typeface="Segoe"/>
+                <a:ea typeface="Segoe"/>
               </a:rPr>
               <a:t/>
             </a:r>
           </a:p>
           <a:p xmlns:a="http://schemas.openxmlformats.org/drawingml/2006/main">
             <a:r>
-              <a:rPr lang="en-US" sz="1600">
-                <a:solidFill>
-                  <a:srgbClr val="333333"/>
-                </a:solidFill>
-                <a:latin typeface="Calibri"/>
-                <a:ea typeface="Calibri"/>
+              <a:rPr lang="en-US" sz="1500">
+                <a:solidFill>
+                  <a:srgbClr val="E2E8F0"/>
+                </a:solidFill>
+                <a:latin typeface="Segoe"/>
+                <a:ea typeface="Segoe"/>
               </a:rPr>
               <a:t>• Requires cryptographic confirmation from both buyer and seller to unlock settlement cell.</a:t>
             </a:r>
           </a:p>
           <a:p xmlns:a="http://schemas.openxmlformats.org/drawingml/2006/main">
             <a:r>
-              <a:rPr lang="en-US" sz="1600">
-                <a:solidFill>
-                  <a:srgbClr val="333333"/>
-                </a:solidFill>
-                <a:latin typeface="Calibri"/>
-                <a:ea typeface="Calibri"/>
+              <a:rPr lang="en-US" sz="1500">
+                <a:solidFill>
+                  <a:srgbClr val="E2E8F0"/>
+                </a:solidFill>
+                <a:latin typeface="Segoe"/>
+                <a:ea typeface="Segoe"/>
               </a:rPr>
               <a:t/>
             </a:r>
           </a:p>
           <a:p xmlns:a="http://schemas.openxmlformats.org/drawingml/2006/main">
             <a:r>
-              <a:rPr lang="en-US" sz="1600">
-                <a:solidFill>
-                  <a:srgbClr val="333333"/>
-                </a:solidFill>
-                <a:latin typeface="Calibri"/>
-                <a:ea typeface="Calibri"/>
+              <a:rPr lang="en-US" sz="1500">
+                <a:solidFill>
+                  <a:srgbClr val="E2E8F0"/>
+                </a:solidFill>
+                <a:latin typeface="Segoe"/>
+                <a:ea typeface="Segoe"/>
               </a:rPr>
               <a:t>• Enforces absolute solvency on every active trade.</a:t>
             </a:r>
@@ -3177,10 +3179,12 @@
             <a:avLst/>
           </a:prstGeom>
           <a:solidFill xmlns:a="http://schemas.openxmlformats.org/drawingml/2006/main">
-            <a:srgbClr val="1E2761"/>
+            <a:srgbClr val="141A20"/>
           </a:solidFill>
           <a:ln xmlns:a="http://schemas.openxmlformats.org/drawingml/2006/main">
-            <a:noFill/>
+            <a:solidFill>
+              <a:srgbClr val="00FF87"/>
+            </a:solidFill>
           </a:ln>
         </p:spPr>
         <p:txBody>
@@ -3212,10 +3216,10 @@
             <a:r>
               <a:rPr lang="en-US" sz="2000" b="1">
                 <a:solidFill>
-                  <a:srgbClr val="CADCFC"/>
-                </a:solidFill>
-                <a:latin typeface="Georgia"/>
-                <a:ea typeface="Georgia"/>
+                  <a:srgbClr val="00FF87"/>
+                </a:solidFill>
+                <a:latin typeface="Inter"/>
+                <a:ea typeface="Inter"/>
               </a:rPr>
               <a:t>3. Toy Passport DOB</a:t>
             </a:r>
@@ -3243,60 +3247,60 @@
           <a:lstStyle xmlns:a="http://schemas.openxmlformats.org/drawingml/2006/main"/>
           <a:p xmlns:a="http://schemas.openxmlformats.org/drawingml/2006/main">
             <a:r>
-              <a:rPr lang="en-US" sz="1600">
-                <a:solidFill>
-                  <a:srgbClr val="FFFFFF"/>
-                </a:solidFill>
-                <a:latin typeface="Calibri"/>
-                <a:ea typeface="Calibri"/>
+              <a:rPr lang="en-US" sz="1500">
+                <a:solidFill>
+                  <a:srgbClr val="E2E8F0"/>
+                </a:solidFill>
+                <a:latin typeface="Segoe"/>
+                <a:ea typeface="Segoe"/>
               </a:rPr>
               <a:t>• Backed by genuine CKB cell capacity.</a:t>
             </a:r>
           </a:p>
           <a:p xmlns:a="http://schemas.openxmlformats.org/drawingml/2006/main">
             <a:r>
-              <a:rPr lang="en-US" sz="1600">
-                <a:solidFill>
-                  <a:srgbClr val="FFFFFF"/>
-                </a:solidFill>
-                <a:latin typeface="Calibri"/>
-                <a:ea typeface="Calibri"/>
+              <a:rPr lang="en-US" sz="1500">
+                <a:solidFill>
+                  <a:srgbClr val="E2E8F0"/>
+                </a:solidFill>
+                <a:latin typeface="Segoe"/>
+                <a:ea typeface="Segoe"/>
               </a:rPr>
               <a:t/>
             </a:r>
           </a:p>
           <a:p xmlns:a="http://schemas.openxmlformats.org/drawingml/2006/main">
             <a:r>
-              <a:rPr lang="en-US" sz="1600">
-                <a:solidFill>
-                  <a:srgbClr val="FFFFFF"/>
-                </a:solidFill>
-                <a:latin typeface="Calibri"/>
-                <a:ea typeface="Calibri"/>
+              <a:rPr lang="en-US" sz="1500">
+                <a:solidFill>
+                  <a:srgbClr val="E2E8F0"/>
+                </a:solidFill>
+                <a:latin typeface="Segoe"/>
+                <a:ea typeface="Segoe"/>
               </a:rPr>
               <a:t>• Holds immutable ownership timeline and parent reviews.</a:t>
             </a:r>
           </a:p>
           <a:p xmlns:a="http://schemas.openxmlformats.org/drawingml/2006/main">
             <a:r>
-              <a:rPr lang="en-US" sz="1600">
-                <a:solidFill>
-                  <a:srgbClr val="FFFFFF"/>
-                </a:solidFill>
-                <a:latin typeface="Calibri"/>
-                <a:ea typeface="Calibri"/>
+              <a:rPr lang="en-US" sz="1500">
+                <a:solidFill>
+                  <a:srgbClr val="E2E8F0"/>
+                </a:solidFill>
+                <a:latin typeface="Segoe"/>
+                <a:ea typeface="Segoe"/>
               </a:rPr>
               <a:t/>
             </a:r>
           </a:p>
           <a:p xmlns:a="http://schemas.openxmlformats.org/drawingml/2006/main">
             <a:r>
-              <a:rPr lang="en-US" sz="1600">
-                <a:solidFill>
-                  <a:srgbClr val="FFFFFF"/>
-                </a:solidFill>
-                <a:latin typeface="Calibri"/>
-                <a:ea typeface="Calibri"/>
+              <a:rPr lang="en-US" sz="1500">
+                <a:solidFill>
+                  <a:srgbClr val="E2E8F0"/>
+                </a:solidFill>
+                <a:latin typeface="Segoe"/>
+                <a:ea typeface="Segoe"/>
               </a:rPr>
               <a:t>• Can never be deleted, forged, or stolen off-chain.</a:t>
             </a:r>
@@ -3314,7 +3318,7 @@
     <p:bg>
       <p:bgPr>
         <a:solidFill xmlns:a="http://schemas.openxmlformats.org/drawingml/2006/main">
-          <a:srgbClr val="1E2761"/>
+          <a:srgbClr val="0A0E12"/>
         </a:solidFill>
       </p:bgPr>
     </p:bg>
@@ -3346,12 +3350,12 @@
           <a:lstStyle xmlns:a="http://schemas.openxmlformats.org/drawingml/2006/main"/>
           <a:p xmlns:a="http://schemas.openxmlformats.org/drawingml/2006/main">
             <a:r>
-              <a:rPr lang="en-US" sz="3800" b="1">
+              <a:rPr lang="en-US" sz="3600" b="1">
                 <a:solidFill>
                   <a:srgbClr val="FFFFFF"/>
                 </a:solidFill>
-                <a:latin typeface="Georgia"/>
-                <a:ea typeface="Georgia"/>
+                <a:latin typeface="Inter"/>
+                <a:ea typeface="Inter"/>
               </a:rPr>
               <a:t>ToyTrade Evolutionary Roadmap</a:t>
             </a:r>
@@ -3373,12 +3377,12 @@
             <a:avLst/>
           </a:prstGeom>
           <a:solidFill xmlns:a="http://schemas.openxmlformats.org/drawingml/2006/main">
-            <a:srgbClr val="FFFFFF">
-              <a:alpha val="8000"/>
-            </a:srgbClr>
+            <a:srgbClr val="141A20"/>
           </a:solidFill>
           <a:ln xmlns:a="http://schemas.openxmlformats.org/drawingml/2006/main">
-            <a:noFill/>
+            <a:solidFill>
+              <a:srgbClr val="00FF87"/>
+            </a:solidFill>
           </a:ln>
         </p:spPr>
         <p:txBody>
@@ -3412,8 +3416,8 @@
                 <a:solidFill>
                   <a:srgbClr val="00FF87"/>
                 </a:solidFill>
-                <a:latin typeface="Georgia"/>
-                <a:ea typeface="Georgia"/>
+                <a:latin typeface="Inter"/>
+                <a:ea typeface="Inter"/>
               </a:rPr>
               <a:t>v1: CKB Escrow</a:t>
             </a:r>
@@ -3441,12 +3445,12 @@
           <a:lstStyle xmlns:a="http://schemas.openxmlformats.org/drawingml/2006/main"/>
           <a:p xmlns:a="http://schemas.openxmlformats.org/drawingml/2006/main">
             <a:r>
-              <a:rPr lang="en-US" sz="1700">
-                <a:solidFill>
-                  <a:srgbClr val="CADCFC"/>
-                </a:solidFill>
-                <a:latin typeface="Calibri"/>
-                <a:ea typeface="Calibri"/>
+              <a:rPr lang="en-US" sz="1600">
+                <a:solidFill>
+                  <a:srgbClr val="E2E8F0"/>
+                </a:solidFill>
+                <a:latin typeface="Segoe"/>
+                <a:ea typeface="Segoe"/>
               </a:rPr>
               <a:t>Core platform featuring listings, custom escrow lock scripts, Toy Passport DOBs, user rating systems, and 3-price dynamic displays.</a:t>
             </a:r>
@@ -3468,12 +3472,12 @@
             <a:avLst/>
           </a:prstGeom>
           <a:solidFill xmlns:a="http://schemas.openxmlformats.org/drawingml/2006/main">
-            <a:srgbClr val="FFFFFF">
-              <a:alpha val="8000"/>
-            </a:srgbClr>
+            <a:srgbClr val="141A20"/>
           </a:solidFill>
           <a:ln xmlns:a="http://schemas.openxmlformats.org/drawingml/2006/main">
-            <a:noFill/>
+            <a:solidFill>
+              <a:srgbClr val="60EFFF"/>
+            </a:solidFill>
           </a:ln>
         </p:spPr>
         <p:txBody>
@@ -3505,10 +3509,10 @@
             <a:r>
               <a:rPr lang="en-US" sz="2200" b="1">
                 <a:solidFill>
-                  <a:srgbClr val="CADCFC"/>
-                </a:solidFill>
-                <a:latin typeface="Georgia"/>
-                <a:ea typeface="Georgia"/>
+                  <a:srgbClr val="60EFFF"/>
+                </a:solidFill>
+                <a:latin typeface="Inter"/>
+                <a:ea typeface="Inter"/>
               </a:rPr>
               <a:t>v2: Fiber Network</a:t>
             </a:r>
@@ -3536,12 +3540,12 @@
           <a:lstStyle xmlns:a="http://schemas.openxmlformats.org/drawingml/2006/main"/>
           <a:p xmlns:a="http://schemas.openxmlformats.org/drawingml/2006/main">
             <a:r>
-              <a:rPr lang="en-US" sz="1700">
-                <a:solidFill>
-                  <a:srgbClr val="8899BB"/>
-                </a:solidFill>
-                <a:latin typeface="Calibri"/>
-                <a:ea typeface="Calibri"/>
+              <a:rPr lang="en-US" sz="1600">
+                <a:solidFill>
+                  <a:srgbClr val="E2E8F0"/>
+                </a:solidFill>
+                <a:latin typeface="Segoe"/>
+                <a:ea typeface="Segoe"/>
               </a:rPr>
               <a:t>Default instant Fiber handover with automated Layer 1 Escrow fallback. Enables sub-second meetup settlement and micro-toy trades.</a:t>
             </a:r>
@@ -3563,12 +3567,12 @@
             <a:avLst/>
           </a:prstGeom>
           <a:solidFill xmlns:a="http://schemas.openxmlformats.org/drawingml/2006/main">
-            <a:srgbClr val="FFFFFF">
-              <a:alpha val="8000"/>
-            </a:srgbClr>
+            <a:srgbClr val="141A20"/>
           </a:solidFill>
           <a:ln xmlns:a="http://schemas.openxmlformats.org/drawingml/2006/main">
-            <a:noFill/>
+            <a:solidFill>
+              <a:srgbClr val="00FF87"/>
+            </a:solidFill>
           </a:ln>
         </p:spPr>
         <p:txBody>
@@ -3600,10 +3604,10 @@
             <a:r>
               <a:rPr lang="en-US" sz="2200" b="1">
                 <a:solidFill>
-                  <a:srgbClr val="CADCFC"/>
-                </a:solidFill>
-                <a:latin typeface="Georgia"/>
-                <a:ea typeface="Georgia"/>
+                  <a:srgbClr val="00FF87"/>
+                </a:solidFill>
+                <a:latin typeface="Inter"/>
+                <a:ea typeface="Inter"/>
               </a:rPr>
               <a:t>v3: Bitcoin Swaps</a:t>
             </a:r>
@@ -3631,12 +3635,12 @@
           <a:lstStyle xmlns:a="http://schemas.openxmlformats.org/drawingml/2006/main"/>
           <a:p xmlns:a="http://schemas.openxmlformats.org/drawingml/2006/main">
             <a:r>
-              <a:rPr lang="en-US" sz="1700">
-                <a:solidFill>
-                  <a:srgbClr val="8899BB"/>
-                </a:solidFill>
-                <a:latin typeface="Calibri"/>
-                <a:ea typeface="Calibri"/>
+              <a:rPr lang="en-US" sz="1600">
+                <a:solidFill>
+                  <a:srgbClr val="E2E8F0"/>
+                </a:solidFill>
+                <a:latin typeface="Segoe"/>
+                <a:ea typeface="Segoe"/>
               </a:rPr>
               <a:t>Leveraging cross-chain hubs to support native Bitcoin settlements as alternative trade settlement options.</a:t>
             </a:r>

</xml_diff>